<commit_message>
deck v3: README summary on slide 2 (iteration 31)
</commit_message>
<xml_diff>
--- a/docs/05-summary/management-deck-v3.pptx
+++ b/docs/05-summary/management-deck-v3.pptx
@@ -120,7 +120,7 @@
   <p:extLst>
     <p:ext uri="{521415D9-36F7-43E2-AB2F-B90AF26B5E84}">
       <p14:sectionLst xmlns:p14="http://schemas.microsoft.com/office/powerpoint/2010/main">
-        <p14:section name="Situation" id="{13eec3ae-b8ed-c8e2-3f42-3cac3d2e6463}">
+        <p14:section name="Situation" id="{024fb8e9-1a3c-abfb-511f-2863d1220213}">
           <p14:sldIdLst>
             <p14:sldId id="256"/>
             <p14:sldId id="257"/>
@@ -128,28 +128,28 @@
             <p14:sldId id="259"/>
           </p14:sldIdLst>
         </p14:section>
-        <p14:section name="Findings" id="{ffdb0fa0-2939-2c89-cb07-118c0bb6dce0}">
+        <p14:section name="Findings" id="{8f75ab49-cb6b-5363-f6fb-9ed6470d810a}">
           <p14:sldIdLst>
             <p14:sldId id="260"/>
             <p14:sldId id="261"/>
             <p14:sldId id="262"/>
           </p14:sldIdLst>
         </p14:section>
-        <p14:section name="Quality model" id="{2839de04-6991-08ea-18af-107431215ac5}">
+        <p14:section name="Quality model" id="{36797db2-4bdb-bae8-37d2-31dcd8beda2a}">
           <p14:sldIdLst>
             <p14:sldId id="263"/>
             <p14:sldId id="264"/>
             <p14:sldId id="265"/>
           </p14:sldIdLst>
         </p14:section>
-        <p14:section name="Action plan" id="{84084a3d-d4d3-24ab-9719-fd9640d81047}">
+        <p14:section name="Action plan" id="{a254a8bf-4d0e-3f01-5159-f643e986f2eb}">
           <p14:sldIdLst>
             <p14:sldId id="266"/>
             <p14:sldId id="267"/>
             <p14:sldId id="268"/>
           </p14:sldIdLst>
         </p14:section>
-        <p14:section name="Decisions" id="{522c4bb7-9ac1-9654-4567-8c4887d56118}">
+        <p14:section name="Decisions" id="{13169f86-5c89-44ee-7b2b-be3e2922319c}">
           <p14:sldIdLst>
             <p14:sldId id="269"/>
           </p14:sldIdLst>
@@ -11083,8 +11083,8 @@
         </p:nvSpPr>
         <p:spPr>
           <a:xfrm>
-            <a:off x="548640" y="4160520"/>
-            <a:ext cx="411480" cy="411480"/>
+            <a:off x="548640" y="4023360"/>
+            <a:ext cx="329184" cy="329184"/>
           </a:xfrm>
           <a:prstGeom prst="ellipse">
             <a:avLst/>
@@ -11108,8 +11108,8 @@
         </p:nvSpPr>
         <p:spPr>
           <a:xfrm>
-            <a:off x="548640" y="4160520"/>
-            <a:ext cx="411480" cy="411480"/>
+            <a:off x="548640" y="4023360"/>
+            <a:ext cx="329184" cy="329184"/>
           </a:xfrm>
           <a:prstGeom prst="rect">
             <a:avLst/>
@@ -11144,8 +11144,8 @@
         </p:nvSpPr>
         <p:spPr>
           <a:xfrm>
-            <a:off x="1143000" y="4160520"/>
-            <a:ext cx="10424160" cy="457200"/>
+            <a:off x="1005840" y="4023360"/>
+            <a:ext cx="10607040" cy="329184"/>
           </a:xfrm>
           <a:prstGeom prst="rect">
             <a:avLst/>
@@ -11161,7 +11161,7 @@
               <a:buNone/>
             </a:pPr>
             <a:r>
-              <a:rPr lang="en-US" sz="1600" b="1" dirty="0">
+              <a:rPr lang="en-US" sz="1500" b="1" dirty="0">
                 <a:solidFill>
                   <a:schemeClr val="tx1"/>
                 </a:solidFill>
@@ -11172,14 +11172,14 @@
               <a:buNone/>
             </a:pPr>
             <a:r>
-              <a:rPr lang="en-US" sz="1600" dirty="0">
+              <a:rPr lang="en-US" sz="1500" dirty="0">
                 <a:solidFill>
                   <a:schemeClr val="tx1"/>
                 </a:solidFill>
               </a:rPr>
-              <a:t> P1/P2 rose sharply; total volume rose a little and fell in Q3.</a:t>
-            </a:r>
-            <a:endParaRPr lang="en-US" sz="1600" dirty="0"/>
+              <a:t> P1/P2 +49%, all bugs +13%; Q3 volume fell.</a:t>
+            </a:r>
+            <a:endParaRPr lang="en-US" sz="1500" dirty="0"/>
           </a:p>
         </p:txBody>
       </p:sp>
@@ -11191,8 +11191,8 @@
         </p:nvSpPr>
         <p:spPr>
           <a:xfrm>
-            <a:off x="548640" y="4846320"/>
-            <a:ext cx="411480" cy="411480"/>
+            <a:off x="548640" y="4453128"/>
+            <a:ext cx="329184" cy="329184"/>
           </a:xfrm>
           <a:prstGeom prst="ellipse">
             <a:avLst/>
@@ -11216,8 +11216,8 @@
         </p:nvSpPr>
         <p:spPr>
           <a:xfrm>
-            <a:off x="548640" y="4846320"/>
-            <a:ext cx="411480" cy="411480"/>
+            <a:off x="548640" y="4453128"/>
+            <a:ext cx="329184" cy="329184"/>
           </a:xfrm>
           <a:prstGeom prst="rect">
             <a:avLst/>
@@ -11252,8 +11252,8 @@
         </p:nvSpPr>
         <p:spPr>
           <a:xfrm>
-            <a:off x="1143000" y="4846320"/>
-            <a:ext cx="10424160" cy="457200"/>
+            <a:off x="1005840" y="4453128"/>
+            <a:ext cx="10607040" cy="329184"/>
           </a:xfrm>
           <a:prstGeom prst="rect">
             <a:avLst/>
@@ -11269,25 +11269,25 @@
               <a:buNone/>
             </a:pPr>
             <a:r>
-              <a:rPr lang="en-US" sz="1600" b="1" dirty="0">
+              <a:rPr lang="en-US" sz="1500" b="1" dirty="0">
                 <a:solidFill>
                   <a:schemeClr val="tx1"/>
                 </a:solidFill>
               </a:rPr>
-              <a:t>Not AI per change:</a:t>
+              <a:t>Customers find problems first:</a:t>
             </a:r>
             <a:pPr indent="0" marL="0">
               <a:buNone/>
             </a:pPr>
             <a:r>
-              <a:rPr lang="en-US" sz="1600" dirty="0">
+              <a:rPr lang="en-US" sz="1500" dirty="0">
                 <a:solidFill>
                   <a:schemeClr val="tx1"/>
                 </a:solidFill>
               </a:rPr>
-              <a:t> matched comparisons show no higher bug rate for AI-made changes.</a:t>
-            </a:r>
-            <a:endParaRPr lang="en-US" sz="1600" dirty="0"/>
+              <a:t> 96% of P1 incidents come via customer cases.</a:t>
+            </a:r>
+            <a:endParaRPr lang="en-US" sz="1500" dirty="0"/>
           </a:p>
         </p:txBody>
       </p:sp>
@@ -11299,8 +11299,224 @@
         </p:nvSpPr>
         <p:spPr>
           <a:xfrm>
-            <a:off x="548640" y="5532120"/>
-            <a:ext cx="411480" cy="411480"/>
+            <a:off x="548640" y="4882896"/>
+            <a:ext cx="329184" cy="329184"/>
+          </a:xfrm>
+          <a:prstGeom prst="ellipse">
+            <a:avLst/>
+          </a:prstGeom>
+          <a:solidFill>
+            <a:schemeClr val="tx1"/>
+          </a:solidFill>
+          <a:ln w="12700">
+            <a:solidFill>
+              <a:schemeClr val="tx1"/>
+            </a:solidFill>
+            <a:prstDash val="solid"/>
+          </a:ln>
+        </p:spPr>
+      </p:sp>
+      <p:sp>
+        <p:nvSpPr>
+          <p:cNvPr id="22" name="Text 20"/>
+          <p:cNvSpPr txBox="1"/>
+          <p:nvPr/>
+        </p:nvSpPr>
+        <p:spPr>
+          <a:xfrm>
+            <a:off x="548640" y="4882896"/>
+            <a:ext cx="329184" cy="329184"/>
+          </a:xfrm>
+          <a:prstGeom prst="rect">
+            <a:avLst/>
+          </a:prstGeom>
+          <a:noFill/>
+          <a:ln/>
+        </p:spPr>
+        <p:txBody>
+          <a:bodyPr wrap="square" lIns="0" tIns="0" rIns="0" bIns="0" rtlCol="0" anchor="ctr"/>
+          <a:lstStyle/>
+          <a:p>
+            <a:pPr algn="ctr" indent="0" marL="0">
+              <a:buNone/>
+            </a:pPr>
+            <a:r>
+              <a:rPr lang="en-US" sz="1600" b="1" dirty="0">
+                <a:solidFill>
+                  <a:schemeClr val="bg1"/>
+                </a:solidFill>
+              </a:rPr>
+              <a:t>3</a:t>
+            </a:r>
+            <a:endParaRPr lang="en-US" sz="1600" dirty="0"/>
+          </a:p>
+        </p:txBody>
+      </p:sp>
+      <p:sp>
+        <p:nvSpPr>
+          <p:cNvPr id="23" name="Text 21"/>
+          <p:cNvSpPr txBox="1"/>
+          <p:nvPr/>
+        </p:nvSpPr>
+        <p:spPr>
+          <a:xfrm>
+            <a:off x="1005840" y="4882896"/>
+            <a:ext cx="10607040" cy="329184"/>
+          </a:xfrm>
+          <a:prstGeom prst="rect">
+            <a:avLst/>
+          </a:prstGeom>
+          <a:noFill/>
+          <a:ln/>
+        </p:spPr>
+        <p:txBody>
+          <a:bodyPr wrap="square" lIns="0" tIns="0" rIns="0" bIns="0" rtlCol="0" anchor="ctr"/>
+          <a:lstStyle/>
+          <a:p>
+            <a:pPr indent="0" marL="0">
+              <a:buNone/>
+            </a:pPr>
+            <a:r>
+              <a:rPr lang="en-US" sz="1500" b="1" dirty="0">
+                <a:solidFill>
+                  <a:schemeClr val="tx1"/>
+                </a:solidFill>
+              </a:rPr>
+              <a:t>Correctness failures:</a:t>
+            </a:r>
+            <a:pPr indent="0" marL="0">
+              <a:buNone/>
+            </a:pPr>
+            <a:r>
+              <a:rPr lang="en-US" sz="1500" dirty="0">
+                <a:solidFill>
+                  <a:schemeClr val="tx1"/>
+                </a:solidFill>
+              </a:rPr>
+              <a:t> almost half of valid bugs (report data, routing, contact lifecycle).</a:t>
+            </a:r>
+            <a:endParaRPr lang="en-US" sz="1500" dirty="0"/>
+          </a:p>
+        </p:txBody>
+      </p:sp>
+      <p:sp>
+        <p:nvSpPr>
+          <p:cNvPr id="24" name="num-4"/>
+          <p:cNvSpPr/>
+          <p:nvPr/>
+        </p:nvSpPr>
+        <p:spPr>
+          <a:xfrm>
+            <a:off x="548640" y="5312664"/>
+            <a:ext cx="329184" cy="329184"/>
+          </a:xfrm>
+          <a:prstGeom prst="ellipse">
+            <a:avLst/>
+          </a:prstGeom>
+          <a:solidFill>
+            <a:schemeClr val="tx1"/>
+          </a:solidFill>
+          <a:ln w="12700">
+            <a:solidFill>
+              <a:schemeClr val="tx1"/>
+            </a:solidFill>
+            <a:prstDash val="solid"/>
+          </a:ln>
+        </p:spPr>
+      </p:sp>
+      <p:sp>
+        <p:nvSpPr>
+          <p:cNvPr id="25" name="Text 23"/>
+          <p:cNvSpPr txBox="1"/>
+          <p:nvPr/>
+        </p:nvSpPr>
+        <p:spPr>
+          <a:xfrm>
+            <a:off x="548640" y="5312664"/>
+            <a:ext cx="329184" cy="329184"/>
+          </a:xfrm>
+          <a:prstGeom prst="rect">
+            <a:avLst/>
+          </a:prstGeom>
+          <a:noFill/>
+          <a:ln/>
+        </p:spPr>
+        <p:txBody>
+          <a:bodyPr wrap="square" lIns="0" tIns="0" rIns="0" bIns="0" rtlCol="0" anchor="ctr"/>
+          <a:lstStyle/>
+          <a:p>
+            <a:pPr algn="ctr" indent="0" marL="0">
+              <a:buNone/>
+            </a:pPr>
+            <a:r>
+              <a:rPr lang="en-US" sz="1600" b="1" dirty="0">
+                <a:solidFill>
+                  <a:schemeClr val="bg1"/>
+                </a:solidFill>
+              </a:rPr>
+              <a:t>4</a:t>
+            </a:r>
+            <a:endParaRPr lang="en-US" sz="1600" dirty="0"/>
+          </a:p>
+        </p:txBody>
+      </p:sp>
+      <p:sp>
+        <p:nvSpPr>
+          <p:cNvPr id="26" name="Text 24"/>
+          <p:cNvSpPr txBox="1"/>
+          <p:nvPr/>
+        </p:nvSpPr>
+        <p:spPr>
+          <a:xfrm>
+            <a:off x="1005840" y="5312664"/>
+            <a:ext cx="10607040" cy="329184"/>
+          </a:xfrm>
+          <a:prstGeom prst="rect">
+            <a:avLst/>
+          </a:prstGeom>
+          <a:noFill/>
+          <a:ln/>
+        </p:spPr>
+        <p:txBody>
+          <a:bodyPr wrap="square" lIns="0" tIns="0" rIns="0" bIns="0" rtlCol="0" anchor="ctr"/>
+          <a:lstStyle/>
+          <a:p>
+            <a:pPr indent="0" marL="0">
+              <a:buNone/>
+            </a:pPr>
+            <a:r>
+              <a:rPr lang="en-US" sz="1500" b="1" dirty="0">
+                <a:solidFill>
+                  <a:schemeClr val="tx1"/>
+                </a:solidFill>
+              </a:rPr>
+              <a:t>AI not riskier per change:</a:t>
+            </a:r>
+            <a:pPr indent="0" marL="0">
+              <a:buNone/>
+            </a:pPr>
+            <a:r>
+              <a:rPr lang="en-US" sz="1500" dirty="0">
+                <a:solidFill>
+                  <a:schemeClr val="tx1"/>
+                </a:solidFill>
+              </a:rPr>
+              <a:t> it adds volume and larger changes in hotspot code.</a:t>
+            </a:r>
+            <a:endParaRPr lang="en-US" sz="1500" dirty="0"/>
+          </a:p>
+        </p:txBody>
+      </p:sp>
+      <p:sp>
+        <p:nvSpPr>
+          <p:cNvPr id="27" name="num-5"/>
+          <p:cNvSpPr/>
+          <p:nvPr/>
+        </p:nvSpPr>
+        <p:spPr>
+          <a:xfrm>
+            <a:off x="548640" y="5742432"/>
+            <a:ext cx="329184" cy="329184"/>
           </a:xfrm>
           <a:prstGeom prst="ellipse">
             <a:avLst/>
@@ -11318,14 +11534,14 @@
       </p:sp>
       <p:sp>
         <p:nvSpPr>
-          <p:cNvPr id="22" name="Text 20"/>
+          <p:cNvPr id="28" name="Text 26"/>
           <p:cNvSpPr txBox="1"/>
           <p:nvPr/>
         </p:nvSpPr>
         <p:spPr>
           <a:xfrm>
-            <a:off x="548640" y="5532120"/>
-            <a:ext cx="411480" cy="411480"/>
+            <a:off x="548640" y="5742432"/>
+            <a:ext cx="329184" cy="329184"/>
           </a:xfrm>
           <a:prstGeom prst="rect">
             <a:avLst/>
@@ -11346,7 +11562,7 @@
                   <a:schemeClr val="bg1"/>
                 </a:solidFill>
               </a:rPr>
-              <a:t>3</a:t>
+              <a:t>5</a:t>
             </a:r>
             <a:endParaRPr lang="en-US" sz="1600" dirty="0"/>
           </a:p>
@@ -11354,14 +11570,14 @@
       </p:sp>
       <p:sp>
         <p:nvSpPr>
-          <p:cNvPr id="23" name="Text 21"/>
+          <p:cNvPr id="29" name="Text 27"/>
           <p:cNvSpPr txBox="1"/>
           <p:nvPr/>
         </p:nvSpPr>
         <p:spPr>
           <a:xfrm>
-            <a:off x="1143000" y="5532120"/>
-            <a:ext cx="10424160" cy="457200"/>
+            <a:off x="1005840" y="5742432"/>
+            <a:ext cx="10607040" cy="329184"/>
           </a:xfrm>
           <a:prstGeom prst="rect">
             <a:avLst/>
@@ -11377,25 +11593,25 @@
               <a:buNone/>
             </a:pPr>
             <a:r>
-              <a:rPr lang="en-US" sz="1600" b="1" dirty="0">
+              <a:rPr lang="en-US" sz="1500" b="1" dirty="0">
                 <a:solidFill>
                   <a:schemeClr val="tx1"/>
                 </a:solidFill>
               </a:rPr>
-              <a:t>Proposal:</a:t>
+              <a:t>Teams differ strongly:</a:t>
             </a:r>
             <a:pPr indent="0" marL="0">
               <a:buNone/>
             </a:pPr>
             <a:r>
-              <a:rPr lang="en-US" sz="1600" dirty="0">
+              <a:rPr lang="en-US" sz="1500" dirty="0">
                 <a:solidFill>
                   <a:schemeClr val="tx1"/>
                 </a:solidFill>
               </a:rPr>
-              <a:t> a quality model with a common baseline, risk-based rules, team adaptation, and 5 experiments.</a:t>
-            </a:r>
-            <a:endParaRPr lang="en-US" sz="1600" dirty="0"/>
+              <a:t> one workflow does not fit all. Plan: measure, test in a few teams, spread.</a:t>
+            </a:r>
+            <a:endParaRPr lang="en-US" sz="1500" dirty="0"/>
           </a:p>
         </p:txBody>
       </p:sp>

</xml_diff>

<commit_message>
deck v3 + web: gates today (iteration 36)
</commit_message>
<xml_diff>
--- a/docs/05-summary/management-deck-v3.pptx
+++ b/docs/05-summary/management-deck-v3.pptx
@@ -19,9 +19,10 @@
     <p:sldId id="267" r:id="rId13"/>
     <p:sldId id="268" r:id="rId14"/>
     <p:sldId id="269" r:id="rId15"/>
+    <p:sldId id="270" r:id="rId16"/>
   </p:sldIdLst>
   <p:notesMasterIdLst>
-    <p:notesMasterId r:id="rId16"/>
+    <p:notesMasterId r:id="rId17"/>
   </p:notesMasterIdLst>
   <p:sldSz cx="12192000" cy="6858000"/>
   <p:notesSz cx="6858000" cy="12192000"/>
@@ -120,7 +121,7 @@
   <p:extLst>
     <p:ext uri="{521415D9-36F7-43E2-AB2F-B90AF26B5E84}">
       <p14:sectionLst xmlns:p14="http://schemas.microsoft.com/office/powerpoint/2010/main">
-        <p14:section name="Situation" id="{024fb8e9-1a3c-abfb-511f-2863d1220213}">
+        <p14:section name="Situation" id="{ae5ea163-3a06-5035-563c-fedb161f69fc}">
           <p14:sldIdLst>
             <p14:sldId id="256"/>
             <p14:sldId id="257"/>
@@ -128,30 +129,31 @@
             <p14:sldId id="259"/>
           </p14:sldIdLst>
         </p14:section>
-        <p14:section name="Findings" id="{8f75ab49-cb6b-5363-f6fb-9ed6470d810a}">
+        <p14:section name="Findings" id="{4d78aeb3-4234-e75a-9aac-f66849aafe7e}">
           <p14:sldIdLst>
             <p14:sldId id="260"/>
             <p14:sldId id="261"/>
             <p14:sldId id="262"/>
           </p14:sldIdLst>
         </p14:section>
-        <p14:section name="Quality model" id="{36797db2-4bdb-bae8-37d2-31dcd8beda2a}">
+        <p14:section name="Quality model" id="{938a1ada-ead4-e433-6c5b-065ecaafe4ae}">
           <p14:sldIdLst>
             <p14:sldId id="263"/>
             <p14:sldId id="264"/>
             <p14:sldId id="265"/>
           </p14:sldIdLst>
         </p14:section>
-        <p14:section name="Action plan" id="{a254a8bf-4d0e-3f01-5159-f643e986f2eb}">
+        <p14:section name="Action plan" id="{aae73ff5-7edc-4fc5-21c0-4ead6f6e3571}">
           <p14:sldIdLst>
             <p14:sldId id="266"/>
             <p14:sldId id="267"/>
             <p14:sldId id="268"/>
+            <p14:sldId id="269"/>
           </p14:sldIdLst>
         </p14:section>
-        <p14:section name="Decisions" id="{13169f86-5c89-44ee-7b2b-be3e2922319c}">
+        <p14:section name="Decisions" id="{ed35c1a1-e0d6-5e1a-cd3b-2bd8ce597a9a}">
           <p14:sldIdLst>
-            <p14:sldId id="269"/>
+            <p14:sldId id="270"/>
           </p14:sldIdLst>
         </p14:section>
       </p14:sectionLst>
@@ -2286,7 +2288,7 @@
           <a:p>
             <a:r>
               <a:rPr lang="en-US" dirty="0"/>
-              <a:t>This answers how our current gate methodology and quality automation fit: they stay as possible means, applied where the evidence shows risk.</a:t>
+              <a:t>Source: read-only check of Confluence (agent catalog 3949003282, mutation hub 4201808311, Go/No-Go master 4213801417) and GitHub rulesets. Not checked: Sonar gate conditions, CXQA-925164.</a:t>
             </a:r>
             <a:endParaRPr lang="en-US" dirty="0"/>
           </a:p>
@@ -2374,7 +2376,7 @@
           <a:p>
             <a:r>
               <a:rPr lang="en-US" dirty="0"/>
-              <a:t>Success by April 2027: every valid bug records type, detected-by and cause; each team sees its 8 dimensions monthly; one correctness type is detected before customers; X1-X5 have results with confidence intervals.</a:t>
+              <a:t>This answers how our current gate methodology and quality automation fit: they stay as possible means, applied where the evidence shows risk.</a:t>
             </a:r>
             <a:endParaRPr lang="en-US" dirty="0"/>
           </a:p>
@@ -2462,7 +2464,7 @@
           <a:p>
             <a:r>
               <a:rPr lang="en-US" dirty="0"/>
-              <a:t>Nothing has been changed in company systems. All data, scripts and decisions are in the research repository.</a:t>
+              <a:t>Success by April 2027: every valid bug records type, detected-by and cause; each team sees its 8 dimensions monthly; one correctness type is detected before customers; X1-X5 have results with confidence intervals.</a:t>
             </a:r>
             <a:endParaRPr lang="en-US" dirty="0"/>
           </a:p>
@@ -2486,6 +2488,94 @@
             <a:fld id="{F7021451-1387-4CA6-816F-3879F97B5CBC}" type="slidenum">
               <a:rPr lang="en-US"/>
               <a:t>14</a:t>
+            </a:fld>
+            <a:endParaRPr lang="en-US"/>
+          </a:p>
+        </p:txBody>
+      </p:sp>
+    </p:spTree>
+    <p:extLst>
+      <p:ext uri="{BB962C8B-B14F-4D97-AF65-F5344CB8AC3E}">
+        <p14:creationId xmlns:p14="http://schemas.microsoft.com/office/powerpoint/2010/main" val="1024086991"/>
+      </p:ext>
+    </p:extLst>
+  </p:cSld>
+  <p:clrMapOvr>
+    <a:masterClrMapping/>
+  </p:clrMapOvr>
+</p:notes>
+</file>
+
+<file path=ppt/notesSlides/notesSlide15.xml><?xml version="1.0" encoding="utf-8"?>
+<p:notes xmlns:a="http://schemas.openxmlformats.org/drawingml/2006/main" xmlns:r="http://schemas.openxmlformats.org/officeDocument/2006/relationships" xmlns:p="http://schemas.openxmlformats.org/presentationml/2006/main">
+  <p:cSld>
+    <p:spTree>
+      <p:nvGrpSpPr>
+        <p:cNvPr id="1" name=""/>
+        <p:cNvGrpSpPr/>
+        <p:nvPr/>
+      </p:nvGrpSpPr>
+      <p:grpSpPr>
+        <a:xfrm>
+          <a:off x="0" y="0"/>
+          <a:ext cx="0" cy="0"/>
+          <a:chOff x="0" y="0"/>
+          <a:chExt cx="0" cy="0"/>
+        </a:xfrm>
+      </p:grpSpPr>
+      <p:sp>
+        <p:nvSpPr>
+          <p:cNvPr id="2" name="Slide Image Placeholder 1"/>
+          <p:cNvSpPr>
+            <a:spLocks noGrp="1" noRot="1" noChangeAspect="1"/>
+          </p:cNvSpPr>
+          <p:nvPr>
+            <p:ph type="sldImg"/>
+          </p:nvPr>
+        </p:nvSpPr>
+        <p:spPr/>
+      </p:sp>
+      <p:sp>
+        <p:nvSpPr>
+          <p:cNvPr id="3" name="Notes Placeholder 2"/>
+          <p:cNvSpPr>
+            <a:spLocks noGrp="1"/>
+          </p:cNvSpPr>
+          <p:nvPr>
+            <p:ph type="body" idx="1"/>
+          </p:nvPr>
+        </p:nvSpPr>
+        <p:spPr/>
+        <p:txBody>
+          <a:bodyPr/>
+          <a:lstStyle/>
+          <a:p>
+            <a:r>
+              <a:rPr lang="en-US" dirty="0"/>
+              <a:t>Nothing has been changed in company systems. All data, scripts and decisions are in the research repository.</a:t>
+            </a:r>
+            <a:endParaRPr lang="en-US" dirty="0"/>
+          </a:p>
+        </p:txBody>
+      </p:sp>
+      <p:sp>
+        <p:nvSpPr>
+          <p:cNvPr id="4" name="Slide Number Placeholder 3"/>
+          <p:cNvSpPr>
+            <a:spLocks noGrp="1"/>
+          </p:cNvSpPr>
+          <p:nvPr>
+            <p:ph type="sldNum" sz="quarter" idx="10"/>
+          </p:nvPr>
+        </p:nvSpPr>
+        <p:spPr/>
+        <p:txBody>
+          <a:bodyPr/>
+          <a:lstStyle/>
+          <a:p>
+            <a:fld id="{F7021451-1387-4CA6-816F-3879F97B5CBC}" type="slidenum">
+              <a:rPr lang="en-US"/>
+              <a:t>15</a:t>
             </a:fld>
             <a:endParaRPr lang="en-US"/>
           </a:p>
@@ -6897,7 +6987,7 @@
                   <a:schemeClr val="tx1"/>
                 </a:solidFill>
               </a:rPr>
-              <a:t>Our gates and quality automation: means, not goals</a:t>
+              <a:t>Gates today: most checks are policy, few block</a:t>
             </a:r>
             <a:endParaRPr lang="en-US" sz="3000" dirty="0"/>
           </a:p>
@@ -6905,7 +6995,1775 @@
       </p:sp>
       <p:graphicFrame>
         <p:nvGraphicFramePr>
-          <p:cNvPr id="13" name="means-table"/>
+          <p:cNvPr id="13" name="gates-today"/>
+          <p:cNvGraphicFramePr>
+            <a:graphicFrameLocks noGrp="1"/>
+          </p:cNvGraphicFramePr>
+          <p:nvPr>
+            <p:extLst>
+              <p:ext uri="{D42A27DB-BD31-4B8C-83A1-F6EECF244321}">
+                <p14:modId xmlns:p14="http://schemas.microsoft.com/office/powerpoint/2010/main" val="1579011935"/>
+              </p:ext>
+            </p:extLst>
+          </p:nvPr>
+        </p:nvGraphicFramePr>
+        <p:xfrm>
+          <a:off x="548640" y="1371600"/>
+          <a:ext cx="6949440" cy="914400"/>
+        </p:xfrm>
+        <a:graphic>
+          <a:graphicData uri="http://schemas.openxmlformats.org/drawingml/2006/table">
+            <a:tbl>
+              <a:tblPr/>
+              <a:tblGrid>
+                <a:gridCol w="2286000"/>
+                <a:gridCol w="3291840"/>
+                <a:gridCol w="1371600"/>
+              </a:tblGrid>
+              <a:tr h="566928">
+                <a:tc>
+                  <a:txBody>
+                    <a:bodyPr/>
+                    <a:lstStyle/>
+                    <a:p>
+                      <a:pPr indent="0" marL="0">
+                        <a:buNone/>
+                      </a:pPr>
+                      <a:r>
+                        <a:rPr lang="en-US" sz="1400" b="1" dirty="0">
+                          <a:solidFill>
+                            <a:srgbClr val="FFFFFF"/>
+                          </a:solidFill>
+                          <a:latin typeface="Calibri" pitchFamily="34" charset="0"/>
+                          <a:ea typeface="Calibri" pitchFamily="34" charset="-122"/>
+                          <a:cs typeface="Calibri" pitchFamily="34" charset="-120"/>
+                        </a:rPr>
+                        <a:t>Check</a:t>
+                      </a:r>
+                      <a:endParaRPr lang="en-US" sz="1400" dirty="0">
+                        <a:latin typeface="Calibri" charset="0"/>
+                        <a:ea typeface="Calibri" charset="0"/>
+                        <a:cs typeface="Calibri" charset="0"/>
+                      </a:endParaRPr>
+                    </a:p>
+                  </a:txBody>
+                  <a:tcPr marL="91440" marR="91440" marT="45720" marB="45720" anchor="ctr">
+                    <a:lnL w="6350" cap="flat" cmpd="sng" algn="ctr">
+                      <a:solidFill>
+                        <a:srgbClr val="DDE3EA"/>
+                      </a:solidFill>
+                      <a:prstDash val="solid"/>
+                      <a:round/>
+                      <a:headEnd type="none" w="med" len="med"/>
+                      <a:tailEnd type="none" w="med" len="med"/>
+                    </a:lnL>
+                    <a:lnR w="6350" cap="flat" cmpd="sng" algn="ctr">
+                      <a:solidFill>
+                        <a:srgbClr val="DDE3EA"/>
+                      </a:solidFill>
+                      <a:prstDash val="solid"/>
+                      <a:round/>
+                      <a:headEnd type="none" w="med" len="med"/>
+                      <a:tailEnd type="none" w="med" len="med"/>
+                    </a:lnR>
+                    <a:lnT w="6350" cap="flat" cmpd="sng" algn="ctr">
+                      <a:solidFill>
+                        <a:srgbClr val="DDE3EA"/>
+                      </a:solidFill>
+                      <a:prstDash val="solid"/>
+                      <a:round/>
+                      <a:headEnd type="none" w="med" len="med"/>
+                      <a:tailEnd type="none" w="med" len="med"/>
+                    </a:lnT>
+                    <a:lnB w="6350" cap="flat" cmpd="sng" algn="ctr">
+                      <a:solidFill>
+                        <a:srgbClr val="DDE3EA"/>
+                      </a:solidFill>
+                      <a:prstDash val="solid"/>
+                      <a:round/>
+                      <a:headEnd type="none" w="med" len="med"/>
+                      <a:tailEnd type="none" w="med" len="med"/>
+                    </a:lnB>
+                    <a:solidFill>
+                      <a:srgbClr val="1B2A41"/>
+                    </a:solidFill>
+                  </a:tcPr>
+                </a:tc>
+                <a:tc>
+                  <a:txBody>
+                    <a:bodyPr/>
+                    <a:lstStyle/>
+                    <a:p>
+                      <a:pPr indent="0" marL="0">
+                        <a:buNone/>
+                      </a:pPr>
+                      <a:r>
+                        <a:rPr lang="en-US" sz="1400" b="1" dirty="0">
+                          <a:solidFill>
+                            <a:srgbClr val="FFFFFF"/>
+                          </a:solidFill>
+                          <a:latin typeface="Calibri" pitchFamily="34" charset="0"/>
+                          <a:ea typeface="Calibri" pitchFamily="34" charset="-122"/>
+                          <a:cs typeface="Calibri" pitchFamily="34" charset="-120"/>
+                        </a:rPr>
+                        <a:t>State on 25 Oct 2026</a:t>
+                      </a:r>
+                      <a:endParaRPr lang="en-US" sz="1400" dirty="0">
+                        <a:latin typeface="Calibri" charset="0"/>
+                        <a:ea typeface="Calibri" charset="0"/>
+                        <a:cs typeface="Calibri" charset="0"/>
+                      </a:endParaRPr>
+                    </a:p>
+                  </a:txBody>
+                  <a:tcPr marL="91440" marR="91440" marT="45720" marB="45720" anchor="ctr">
+                    <a:lnL w="6350" cap="flat" cmpd="sng" algn="ctr">
+                      <a:solidFill>
+                        <a:srgbClr val="DDE3EA"/>
+                      </a:solidFill>
+                      <a:prstDash val="solid"/>
+                      <a:round/>
+                      <a:headEnd type="none" w="med" len="med"/>
+                      <a:tailEnd type="none" w="med" len="med"/>
+                    </a:lnL>
+                    <a:lnR w="6350" cap="flat" cmpd="sng" algn="ctr">
+                      <a:solidFill>
+                        <a:srgbClr val="DDE3EA"/>
+                      </a:solidFill>
+                      <a:prstDash val="solid"/>
+                      <a:round/>
+                      <a:headEnd type="none" w="med" len="med"/>
+                      <a:tailEnd type="none" w="med" len="med"/>
+                    </a:lnR>
+                    <a:lnT w="6350" cap="flat" cmpd="sng" algn="ctr">
+                      <a:solidFill>
+                        <a:srgbClr val="DDE3EA"/>
+                      </a:solidFill>
+                      <a:prstDash val="solid"/>
+                      <a:round/>
+                      <a:headEnd type="none" w="med" len="med"/>
+                      <a:tailEnd type="none" w="med" len="med"/>
+                    </a:lnT>
+                    <a:lnB w="6350" cap="flat" cmpd="sng" algn="ctr">
+                      <a:solidFill>
+                        <a:srgbClr val="DDE3EA"/>
+                      </a:solidFill>
+                      <a:prstDash val="solid"/>
+                      <a:round/>
+                      <a:headEnd type="none" w="med" len="med"/>
+                      <a:tailEnd type="none" w="med" len="med"/>
+                    </a:lnB>
+                    <a:solidFill>
+                      <a:srgbClr val="1B2A41"/>
+                    </a:solidFill>
+                  </a:tcPr>
+                </a:tc>
+                <a:tc>
+                  <a:txBody>
+                    <a:bodyPr/>
+                    <a:lstStyle/>
+                    <a:p>
+                      <a:pPr indent="0" marL="0">
+                        <a:buNone/>
+                      </a:pPr>
+                      <a:r>
+                        <a:rPr lang="en-US" sz="1400" b="1" dirty="0">
+                          <a:solidFill>
+                            <a:srgbClr val="FFFFFF"/>
+                          </a:solidFill>
+                          <a:latin typeface="Calibri" pitchFamily="34" charset="0"/>
+                          <a:ea typeface="Calibri" pitchFamily="34" charset="-122"/>
+                          <a:cs typeface="Calibri" pitchFamily="34" charset="-120"/>
+                        </a:rPr>
+                        <a:t>Blocks?</a:t>
+                      </a:r>
+                      <a:endParaRPr lang="en-US" sz="1400" dirty="0">
+                        <a:latin typeface="Calibri" charset="0"/>
+                        <a:ea typeface="Calibri" charset="0"/>
+                        <a:cs typeface="Calibri" charset="0"/>
+                      </a:endParaRPr>
+                    </a:p>
+                  </a:txBody>
+                  <a:tcPr marL="91440" marR="91440" marT="45720" marB="45720" anchor="ctr">
+                    <a:lnL w="6350" cap="flat" cmpd="sng" algn="ctr">
+                      <a:solidFill>
+                        <a:srgbClr val="DDE3EA"/>
+                      </a:solidFill>
+                      <a:prstDash val="solid"/>
+                      <a:round/>
+                      <a:headEnd type="none" w="med" len="med"/>
+                      <a:tailEnd type="none" w="med" len="med"/>
+                    </a:lnL>
+                    <a:lnR w="6350" cap="flat" cmpd="sng" algn="ctr">
+                      <a:solidFill>
+                        <a:srgbClr val="DDE3EA"/>
+                      </a:solidFill>
+                      <a:prstDash val="solid"/>
+                      <a:round/>
+                      <a:headEnd type="none" w="med" len="med"/>
+                      <a:tailEnd type="none" w="med" len="med"/>
+                    </a:lnR>
+                    <a:lnT w="6350" cap="flat" cmpd="sng" algn="ctr">
+                      <a:solidFill>
+                        <a:srgbClr val="DDE3EA"/>
+                      </a:solidFill>
+                      <a:prstDash val="solid"/>
+                      <a:round/>
+                      <a:headEnd type="none" w="med" len="med"/>
+                      <a:tailEnd type="none" w="med" len="med"/>
+                    </a:lnT>
+                    <a:lnB w="6350" cap="flat" cmpd="sng" algn="ctr">
+                      <a:solidFill>
+                        <a:srgbClr val="DDE3EA"/>
+                      </a:solidFill>
+                      <a:prstDash val="solid"/>
+                      <a:round/>
+                      <a:headEnd type="none" w="med" len="med"/>
+                      <a:tailEnd type="none" w="med" len="med"/>
+                    </a:lnB>
+                    <a:solidFill>
+                      <a:srgbClr val="1B2A41"/>
+                    </a:solidFill>
+                  </a:tcPr>
+                </a:tc>
+              </a:tr>
+              <a:tr h="566928">
+                <a:tc>
+                  <a:txBody>
+                    <a:bodyPr/>
+                    <a:lstStyle/>
+                    <a:p>
+                      <a:pPr indent="0" marL="0">
+                        <a:buNone/>
+                      </a:pPr>
+                      <a:r>
+                        <a:rPr lang="en-US" sz="1400" b="1" dirty="0">
+                          <a:solidFill>
+                            <a:srgbClr val="1B2A41"/>
+                          </a:solidFill>
+                          <a:latin typeface="Calibri" pitchFamily="34" charset="0"/>
+                          <a:ea typeface="Calibri" pitchFamily="34" charset="-122"/>
+                          <a:cs typeface="Calibri" pitchFamily="34" charset="-120"/>
+                        </a:rPr>
+                        <a:t>QA agents (8 listed)</a:t>
+                      </a:r>
+                      <a:endParaRPr lang="en-US" sz="1400" dirty="0">
+                        <a:latin typeface="Calibri" charset="0"/>
+                        <a:ea typeface="Calibri" charset="0"/>
+                        <a:cs typeface="Calibri" charset="0"/>
+                      </a:endParaRPr>
+                    </a:p>
+                  </a:txBody>
+                  <a:tcPr marL="91440" marR="91440" marT="45720" marB="45720" anchor="ctr">
+                    <a:lnL w="6350" cap="flat" cmpd="sng" algn="ctr">
+                      <a:solidFill>
+                        <a:srgbClr val="DDE3EA"/>
+                      </a:solidFill>
+                      <a:prstDash val="solid"/>
+                      <a:round/>
+                      <a:headEnd type="none" w="med" len="med"/>
+                      <a:tailEnd type="none" w="med" len="med"/>
+                    </a:lnL>
+                    <a:lnR w="6350" cap="flat" cmpd="sng" algn="ctr">
+                      <a:solidFill>
+                        <a:srgbClr val="DDE3EA"/>
+                      </a:solidFill>
+                      <a:prstDash val="solid"/>
+                      <a:round/>
+                      <a:headEnd type="none" w="med" len="med"/>
+                      <a:tailEnd type="none" w="med" len="med"/>
+                    </a:lnR>
+                    <a:lnT w="6350" cap="flat" cmpd="sng" algn="ctr">
+                      <a:solidFill>
+                        <a:srgbClr val="DDE3EA"/>
+                      </a:solidFill>
+                      <a:prstDash val="solid"/>
+                      <a:round/>
+                      <a:headEnd type="none" w="med" len="med"/>
+                      <a:tailEnd type="none" w="med" len="med"/>
+                    </a:lnT>
+                    <a:lnB w="6350" cap="flat" cmpd="sng" algn="ctr">
+                      <a:solidFill>
+                        <a:srgbClr val="DDE3EA"/>
+                      </a:solidFill>
+                      <a:prstDash val="solid"/>
+                      <a:round/>
+                      <a:headEnd type="none" w="med" len="med"/>
+                      <a:tailEnd type="none" w="med" len="med"/>
+                    </a:lnB>
+                    <a:solidFill>
+                      <a:srgbClr val="EEF2F6"/>
+                    </a:solidFill>
+                  </a:tcPr>
+                </a:tc>
+                <a:tc>
+                  <a:txBody>
+                    <a:bodyPr/>
+                    <a:lstStyle/>
+                    <a:p>
+                      <a:pPr indent="0" marL="0">
+                        <a:buNone/>
+                      </a:pPr>
+                      <a:r>
+                        <a:rPr lang="en-US" sz="1400" dirty="0">
+                          <a:solidFill>
+                            <a:srgbClr val="1B2A41"/>
+                          </a:solidFill>
+                          <a:latin typeface="Calibri" pitchFamily="34" charset="0"/>
+                          <a:ea typeface="Calibri" pitchFamily="34" charset="-122"/>
+                          <a:cs typeface="Calibri" pitchFamily="34" charset="-120"/>
+                        </a:rPr>
+                        <a:t>All run locally, by choice</a:t>
+                      </a:r>
+                      <a:endParaRPr lang="en-US" sz="1400" dirty="0">
+                        <a:latin typeface="Calibri" charset="0"/>
+                        <a:ea typeface="Calibri" charset="0"/>
+                        <a:cs typeface="Calibri" charset="0"/>
+                      </a:endParaRPr>
+                    </a:p>
+                  </a:txBody>
+                  <a:tcPr marL="91440" marR="91440" marT="45720" marB="45720" anchor="ctr">
+                    <a:lnL w="6350" cap="flat" cmpd="sng" algn="ctr">
+                      <a:solidFill>
+                        <a:srgbClr val="DDE3EA"/>
+                      </a:solidFill>
+                      <a:prstDash val="solid"/>
+                      <a:round/>
+                      <a:headEnd type="none" w="med" len="med"/>
+                      <a:tailEnd type="none" w="med" len="med"/>
+                    </a:lnL>
+                    <a:lnR w="6350" cap="flat" cmpd="sng" algn="ctr">
+                      <a:solidFill>
+                        <a:srgbClr val="DDE3EA"/>
+                      </a:solidFill>
+                      <a:prstDash val="solid"/>
+                      <a:round/>
+                      <a:headEnd type="none" w="med" len="med"/>
+                      <a:tailEnd type="none" w="med" len="med"/>
+                    </a:lnR>
+                    <a:lnT w="6350" cap="flat" cmpd="sng" algn="ctr">
+                      <a:solidFill>
+                        <a:srgbClr val="DDE3EA"/>
+                      </a:solidFill>
+                      <a:prstDash val="solid"/>
+                      <a:round/>
+                      <a:headEnd type="none" w="med" len="med"/>
+                      <a:tailEnd type="none" w="med" len="med"/>
+                    </a:lnT>
+                    <a:lnB w="6350" cap="flat" cmpd="sng" algn="ctr">
+                      <a:solidFill>
+                        <a:srgbClr val="DDE3EA"/>
+                      </a:solidFill>
+                      <a:prstDash val="solid"/>
+                      <a:round/>
+                      <a:headEnd type="none" w="med" len="med"/>
+                      <a:tailEnd type="none" w="med" len="med"/>
+                    </a:lnB>
+                    <a:solidFill>
+                      <a:srgbClr val="EEF2F6"/>
+                    </a:solidFill>
+                  </a:tcPr>
+                </a:tc>
+                <a:tc>
+                  <a:txBody>
+                    <a:bodyPr/>
+                    <a:lstStyle/>
+                    <a:p>
+                      <a:pPr indent="0" marL="0">
+                        <a:buNone/>
+                      </a:pPr>
+                      <a:r>
+                        <a:rPr lang="en-US" sz="1400" dirty="0">
+                          <a:solidFill>
+                            <a:srgbClr val="C8443D"/>
+                          </a:solidFill>
+                          <a:latin typeface="Calibri" pitchFamily="34" charset="0"/>
+                          <a:ea typeface="Calibri" pitchFamily="34" charset="-122"/>
+                          <a:cs typeface="Calibri" pitchFamily="34" charset="-120"/>
+                        </a:rPr>
+                        <a:t>No</a:t>
+                      </a:r>
+                      <a:endParaRPr lang="en-US" sz="1400" dirty="0">
+                        <a:latin typeface="Calibri" charset="0"/>
+                        <a:ea typeface="Calibri" charset="0"/>
+                        <a:cs typeface="Calibri" charset="0"/>
+                      </a:endParaRPr>
+                    </a:p>
+                  </a:txBody>
+                  <a:tcPr marL="91440" marR="91440" marT="45720" marB="45720" anchor="ctr">
+                    <a:lnL w="6350" cap="flat" cmpd="sng" algn="ctr">
+                      <a:solidFill>
+                        <a:srgbClr val="DDE3EA"/>
+                      </a:solidFill>
+                      <a:prstDash val="solid"/>
+                      <a:round/>
+                      <a:headEnd type="none" w="med" len="med"/>
+                      <a:tailEnd type="none" w="med" len="med"/>
+                    </a:lnL>
+                    <a:lnR w="6350" cap="flat" cmpd="sng" algn="ctr">
+                      <a:solidFill>
+                        <a:srgbClr val="DDE3EA"/>
+                      </a:solidFill>
+                      <a:prstDash val="solid"/>
+                      <a:round/>
+                      <a:headEnd type="none" w="med" len="med"/>
+                      <a:tailEnd type="none" w="med" len="med"/>
+                    </a:lnR>
+                    <a:lnT w="6350" cap="flat" cmpd="sng" algn="ctr">
+                      <a:solidFill>
+                        <a:srgbClr val="DDE3EA"/>
+                      </a:solidFill>
+                      <a:prstDash val="solid"/>
+                      <a:round/>
+                      <a:headEnd type="none" w="med" len="med"/>
+                      <a:tailEnd type="none" w="med" len="med"/>
+                    </a:lnT>
+                    <a:lnB w="6350" cap="flat" cmpd="sng" algn="ctr">
+                      <a:solidFill>
+                        <a:srgbClr val="DDE3EA"/>
+                      </a:solidFill>
+                      <a:prstDash val="solid"/>
+                      <a:round/>
+                      <a:headEnd type="none" w="med" len="med"/>
+                      <a:tailEnd type="none" w="med" len="med"/>
+                    </a:lnB>
+                    <a:solidFill>
+                      <a:srgbClr val="EEF2F6"/>
+                    </a:solidFill>
+                  </a:tcPr>
+                </a:tc>
+              </a:tr>
+              <a:tr h="566928">
+                <a:tc>
+                  <a:txBody>
+                    <a:bodyPr/>
+                    <a:lstStyle/>
+                    <a:p>
+                      <a:pPr indent="0" marL="0">
+                        <a:buNone/>
+                      </a:pPr>
+                      <a:r>
+                        <a:rPr lang="en-US" sz="1400" b="1" dirty="0">
+                          <a:solidFill>
+                            <a:srgbClr val="1B2A41"/>
+                          </a:solidFill>
+                          <a:latin typeface="Calibri" pitchFamily="34" charset="0"/>
+                          <a:ea typeface="Calibri" pitchFamily="34" charset="-122"/>
+                          <a:cs typeface="Calibri" pitchFamily="34" charset="-120"/>
+                        </a:rPr>
+                        <a:t>Aikido, PR and Jira-ID checks</a:t>
+                      </a:r>
+                      <a:endParaRPr lang="en-US" sz="1400" dirty="0">
+                        <a:latin typeface="Calibri" charset="0"/>
+                        <a:ea typeface="Calibri" charset="0"/>
+                        <a:cs typeface="Calibri" charset="0"/>
+                      </a:endParaRPr>
+                    </a:p>
+                  </a:txBody>
+                  <a:tcPr marL="91440" marR="91440" marT="45720" marB="45720" anchor="ctr">
+                    <a:lnL w="6350" cap="flat" cmpd="sng" algn="ctr">
+                      <a:solidFill>
+                        <a:srgbClr val="DDE3EA"/>
+                      </a:solidFill>
+                      <a:prstDash val="solid"/>
+                      <a:round/>
+                      <a:headEnd type="none" w="med" len="med"/>
+                      <a:tailEnd type="none" w="med" len="med"/>
+                    </a:lnL>
+                    <a:lnR w="6350" cap="flat" cmpd="sng" algn="ctr">
+                      <a:solidFill>
+                        <a:srgbClr val="DDE3EA"/>
+                      </a:solidFill>
+                      <a:prstDash val="solid"/>
+                      <a:round/>
+                      <a:headEnd type="none" w="med" len="med"/>
+                      <a:tailEnd type="none" w="med" len="med"/>
+                    </a:lnR>
+                    <a:lnT w="6350" cap="flat" cmpd="sng" algn="ctr">
+                      <a:solidFill>
+                        <a:srgbClr val="DDE3EA"/>
+                      </a:solidFill>
+                      <a:prstDash val="solid"/>
+                      <a:round/>
+                      <a:headEnd type="none" w="med" len="med"/>
+                      <a:tailEnd type="none" w="med" len="med"/>
+                    </a:lnT>
+                    <a:lnB w="6350" cap="flat" cmpd="sng" algn="ctr">
+                      <a:solidFill>
+                        <a:srgbClr val="DDE3EA"/>
+                      </a:solidFill>
+                      <a:prstDash val="solid"/>
+                      <a:round/>
+                      <a:headEnd type="none" w="med" len="med"/>
+                      <a:tailEnd type="none" w="med" len="med"/>
+                    </a:lnB>
+                    <a:solidFill>
+                      <a:srgbClr val="FFFFFF"/>
+                    </a:solidFill>
+                  </a:tcPr>
+                </a:tc>
+                <a:tc>
+                  <a:txBody>
+                    <a:bodyPr/>
+                    <a:lstStyle/>
+                    <a:p>
+                      <a:pPr indent="0" marL="0">
+                        <a:buNone/>
+                      </a:pPr>
+                      <a:r>
+                        <a:rPr lang="en-US" sz="1400" dirty="0">
+                          <a:solidFill>
+                            <a:srgbClr val="1B2A41"/>
+                          </a:solidFill>
+                          <a:latin typeface="Calibri" pitchFamily="34" charset="0"/>
+                          <a:ea typeface="Calibri" pitchFamily="34" charset="-122"/>
+                          <a:cs typeface="Calibri" pitchFamily="34" charset="-120"/>
+                        </a:rPr>
+                        <a:t>Required in all checked repos</a:t>
+                      </a:r>
+                      <a:endParaRPr lang="en-US" sz="1400" dirty="0">
+                        <a:latin typeface="Calibri" charset="0"/>
+                        <a:ea typeface="Calibri" charset="0"/>
+                        <a:cs typeface="Calibri" charset="0"/>
+                      </a:endParaRPr>
+                    </a:p>
+                  </a:txBody>
+                  <a:tcPr marL="91440" marR="91440" marT="45720" marB="45720" anchor="ctr">
+                    <a:lnL w="6350" cap="flat" cmpd="sng" algn="ctr">
+                      <a:solidFill>
+                        <a:srgbClr val="DDE3EA"/>
+                      </a:solidFill>
+                      <a:prstDash val="solid"/>
+                      <a:round/>
+                      <a:headEnd type="none" w="med" len="med"/>
+                      <a:tailEnd type="none" w="med" len="med"/>
+                    </a:lnL>
+                    <a:lnR w="6350" cap="flat" cmpd="sng" algn="ctr">
+                      <a:solidFill>
+                        <a:srgbClr val="DDE3EA"/>
+                      </a:solidFill>
+                      <a:prstDash val="solid"/>
+                      <a:round/>
+                      <a:headEnd type="none" w="med" len="med"/>
+                      <a:tailEnd type="none" w="med" len="med"/>
+                    </a:lnR>
+                    <a:lnT w="6350" cap="flat" cmpd="sng" algn="ctr">
+                      <a:solidFill>
+                        <a:srgbClr val="DDE3EA"/>
+                      </a:solidFill>
+                      <a:prstDash val="solid"/>
+                      <a:round/>
+                      <a:headEnd type="none" w="med" len="med"/>
+                      <a:tailEnd type="none" w="med" len="med"/>
+                    </a:lnT>
+                    <a:lnB w="6350" cap="flat" cmpd="sng" algn="ctr">
+                      <a:solidFill>
+                        <a:srgbClr val="DDE3EA"/>
+                      </a:solidFill>
+                      <a:prstDash val="solid"/>
+                      <a:round/>
+                      <a:headEnd type="none" w="med" len="med"/>
+                      <a:tailEnd type="none" w="med" len="med"/>
+                    </a:lnB>
+                    <a:solidFill>
+                      <a:srgbClr val="FFFFFF"/>
+                    </a:solidFill>
+                  </a:tcPr>
+                </a:tc>
+                <a:tc>
+                  <a:txBody>
+                    <a:bodyPr/>
+                    <a:lstStyle/>
+                    <a:p>
+                      <a:pPr indent="0" marL="0">
+                        <a:buNone/>
+                      </a:pPr>
+                      <a:r>
+                        <a:rPr lang="en-US" sz="1400" dirty="0">
+                          <a:solidFill>
+                            <a:srgbClr val="1B2A41"/>
+                          </a:solidFill>
+                          <a:latin typeface="Calibri" pitchFamily="34" charset="0"/>
+                          <a:ea typeface="Calibri" pitchFamily="34" charset="-122"/>
+                          <a:cs typeface="Calibri" pitchFamily="34" charset="-120"/>
+                        </a:rPr>
+                        <a:t>Yes</a:t>
+                      </a:r>
+                      <a:endParaRPr lang="en-US" sz="1400" dirty="0">
+                        <a:latin typeface="Calibri" charset="0"/>
+                        <a:ea typeface="Calibri" charset="0"/>
+                        <a:cs typeface="Calibri" charset="0"/>
+                      </a:endParaRPr>
+                    </a:p>
+                  </a:txBody>
+                  <a:tcPr marL="91440" marR="91440" marT="45720" marB="45720" anchor="ctr">
+                    <a:lnL w="6350" cap="flat" cmpd="sng" algn="ctr">
+                      <a:solidFill>
+                        <a:srgbClr val="DDE3EA"/>
+                      </a:solidFill>
+                      <a:prstDash val="solid"/>
+                      <a:round/>
+                      <a:headEnd type="none" w="med" len="med"/>
+                      <a:tailEnd type="none" w="med" len="med"/>
+                    </a:lnL>
+                    <a:lnR w="6350" cap="flat" cmpd="sng" algn="ctr">
+                      <a:solidFill>
+                        <a:srgbClr val="DDE3EA"/>
+                      </a:solidFill>
+                      <a:prstDash val="solid"/>
+                      <a:round/>
+                      <a:headEnd type="none" w="med" len="med"/>
+                      <a:tailEnd type="none" w="med" len="med"/>
+                    </a:lnR>
+                    <a:lnT w="6350" cap="flat" cmpd="sng" algn="ctr">
+                      <a:solidFill>
+                        <a:srgbClr val="DDE3EA"/>
+                      </a:solidFill>
+                      <a:prstDash val="solid"/>
+                      <a:round/>
+                      <a:headEnd type="none" w="med" len="med"/>
+                      <a:tailEnd type="none" w="med" len="med"/>
+                    </a:lnT>
+                    <a:lnB w="6350" cap="flat" cmpd="sng" algn="ctr">
+                      <a:solidFill>
+                        <a:srgbClr val="DDE3EA"/>
+                      </a:solidFill>
+                      <a:prstDash val="solid"/>
+                      <a:round/>
+                      <a:headEnd type="none" w="med" len="med"/>
+                      <a:tailEnd type="none" w="med" len="med"/>
+                    </a:lnB>
+                    <a:solidFill>
+                      <a:srgbClr val="FFFFFF"/>
+                    </a:solidFill>
+                  </a:tcPr>
+                </a:tc>
+              </a:tr>
+              <a:tr h="566928">
+                <a:tc>
+                  <a:txBody>
+                    <a:bodyPr/>
+                    <a:lstStyle/>
+                    <a:p>
+                      <a:pPr indent="0" marL="0">
+                        <a:buNone/>
+                      </a:pPr>
+                      <a:r>
+                        <a:rPr lang="en-US" sz="1400" b="1" dirty="0">
+                          <a:solidFill>
+                            <a:srgbClr val="1B2A41"/>
+                          </a:solidFill>
+                          <a:latin typeface="Calibri" pitchFamily="34" charset="0"/>
+                          <a:ea typeface="Calibri" pitchFamily="34" charset="-122"/>
+                          <a:cs typeface="Calibri" pitchFamily="34" charset="-120"/>
+                        </a:rPr>
+                        <a:t>Sonar</a:t>
+                      </a:r>
+                      <a:endParaRPr lang="en-US" sz="1400" dirty="0">
+                        <a:latin typeface="Calibri" charset="0"/>
+                        <a:ea typeface="Calibri" charset="0"/>
+                        <a:cs typeface="Calibri" charset="0"/>
+                      </a:endParaRPr>
+                    </a:p>
+                  </a:txBody>
+                  <a:tcPr marL="91440" marR="91440" marT="45720" marB="45720" anchor="ctr">
+                    <a:lnL w="6350" cap="flat" cmpd="sng" algn="ctr">
+                      <a:solidFill>
+                        <a:srgbClr val="DDE3EA"/>
+                      </a:solidFill>
+                      <a:prstDash val="solid"/>
+                      <a:round/>
+                      <a:headEnd type="none" w="med" len="med"/>
+                      <a:tailEnd type="none" w="med" len="med"/>
+                    </a:lnL>
+                    <a:lnR w="6350" cap="flat" cmpd="sng" algn="ctr">
+                      <a:solidFill>
+                        <a:srgbClr val="DDE3EA"/>
+                      </a:solidFill>
+                      <a:prstDash val="solid"/>
+                      <a:round/>
+                      <a:headEnd type="none" w="med" len="med"/>
+                      <a:tailEnd type="none" w="med" len="med"/>
+                    </a:lnR>
+                    <a:lnT w="6350" cap="flat" cmpd="sng" algn="ctr">
+                      <a:solidFill>
+                        <a:srgbClr val="DDE3EA"/>
+                      </a:solidFill>
+                      <a:prstDash val="solid"/>
+                      <a:round/>
+                      <a:headEnd type="none" w="med" len="med"/>
+                      <a:tailEnd type="none" w="med" len="med"/>
+                    </a:lnT>
+                    <a:lnB w="6350" cap="flat" cmpd="sng" algn="ctr">
+                      <a:solidFill>
+                        <a:srgbClr val="DDE3EA"/>
+                      </a:solidFill>
+                      <a:prstDash val="solid"/>
+                      <a:round/>
+                      <a:headEnd type="none" w="med" len="med"/>
+                      <a:tailEnd type="none" w="med" len="med"/>
+                    </a:lnB>
+                    <a:solidFill>
+                      <a:srgbClr val="EEF2F6"/>
+                    </a:solidFill>
+                  </a:tcPr>
+                </a:tc>
+                <a:tc>
+                  <a:txBody>
+                    <a:bodyPr/>
+                    <a:lstStyle/>
+                    <a:p>
+                      <a:pPr indent="0" marL="0">
+                        <a:buNone/>
+                      </a:pPr>
+                      <a:r>
+                        <a:rPr lang="en-US" sz="1400" dirty="0">
+                          <a:solidFill>
+                            <a:srgbClr val="1B2A41"/>
+                          </a:solidFill>
+                          <a:latin typeface="Calibri" pitchFamily="34" charset="0"/>
+                          <a:ea typeface="Calibri" pitchFamily="34" charset="-122"/>
+                          <a:cs typeface="Calibri" pitchFamily="34" charset="-120"/>
+                        </a:rPr>
+                        <a:t>Runs in CI; required in 1 of 5 pilot repos</a:t>
+                      </a:r>
+                      <a:endParaRPr lang="en-US" sz="1400" dirty="0">
+                        <a:latin typeface="Calibri" charset="0"/>
+                        <a:ea typeface="Calibri" charset="0"/>
+                        <a:cs typeface="Calibri" charset="0"/>
+                      </a:endParaRPr>
+                    </a:p>
+                  </a:txBody>
+                  <a:tcPr marL="91440" marR="91440" marT="45720" marB="45720" anchor="ctr">
+                    <a:lnL w="6350" cap="flat" cmpd="sng" algn="ctr">
+                      <a:solidFill>
+                        <a:srgbClr val="DDE3EA"/>
+                      </a:solidFill>
+                      <a:prstDash val="solid"/>
+                      <a:round/>
+                      <a:headEnd type="none" w="med" len="med"/>
+                      <a:tailEnd type="none" w="med" len="med"/>
+                    </a:lnL>
+                    <a:lnR w="6350" cap="flat" cmpd="sng" algn="ctr">
+                      <a:solidFill>
+                        <a:srgbClr val="DDE3EA"/>
+                      </a:solidFill>
+                      <a:prstDash val="solid"/>
+                      <a:round/>
+                      <a:headEnd type="none" w="med" len="med"/>
+                      <a:tailEnd type="none" w="med" len="med"/>
+                    </a:lnR>
+                    <a:lnT w="6350" cap="flat" cmpd="sng" algn="ctr">
+                      <a:solidFill>
+                        <a:srgbClr val="DDE3EA"/>
+                      </a:solidFill>
+                      <a:prstDash val="solid"/>
+                      <a:round/>
+                      <a:headEnd type="none" w="med" len="med"/>
+                      <a:tailEnd type="none" w="med" len="med"/>
+                    </a:lnT>
+                    <a:lnB w="6350" cap="flat" cmpd="sng" algn="ctr">
+                      <a:solidFill>
+                        <a:srgbClr val="DDE3EA"/>
+                      </a:solidFill>
+                      <a:prstDash val="solid"/>
+                      <a:round/>
+                      <a:headEnd type="none" w="med" len="med"/>
+                      <a:tailEnd type="none" w="med" len="med"/>
+                    </a:lnB>
+                    <a:solidFill>
+                      <a:srgbClr val="EEF2F6"/>
+                    </a:solidFill>
+                  </a:tcPr>
+                </a:tc>
+                <a:tc>
+                  <a:txBody>
+                    <a:bodyPr/>
+                    <a:lstStyle/>
+                    <a:p>
+                      <a:pPr indent="0" marL="0">
+                        <a:buNone/>
+                      </a:pPr>
+                      <a:r>
+                        <a:rPr lang="en-US" sz="1400" dirty="0">
+                          <a:solidFill>
+                            <a:srgbClr val="1B2A41"/>
+                          </a:solidFill>
+                          <a:latin typeface="Calibri" pitchFamily="34" charset="0"/>
+                          <a:ea typeface="Calibri" pitchFamily="34" charset="-122"/>
+                          <a:cs typeface="Calibri" pitchFamily="34" charset="-120"/>
+                        </a:rPr>
+                        <a:t>Partly</a:t>
+                      </a:r>
+                      <a:endParaRPr lang="en-US" sz="1400" dirty="0">
+                        <a:latin typeface="Calibri" charset="0"/>
+                        <a:ea typeface="Calibri" charset="0"/>
+                        <a:cs typeface="Calibri" charset="0"/>
+                      </a:endParaRPr>
+                    </a:p>
+                  </a:txBody>
+                  <a:tcPr marL="91440" marR="91440" marT="45720" marB="45720" anchor="ctr">
+                    <a:lnL w="6350" cap="flat" cmpd="sng" algn="ctr">
+                      <a:solidFill>
+                        <a:srgbClr val="DDE3EA"/>
+                      </a:solidFill>
+                      <a:prstDash val="solid"/>
+                      <a:round/>
+                      <a:headEnd type="none" w="med" len="med"/>
+                      <a:tailEnd type="none" w="med" len="med"/>
+                    </a:lnL>
+                    <a:lnR w="6350" cap="flat" cmpd="sng" algn="ctr">
+                      <a:solidFill>
+                        <a:srgbClr val="DDE3EA"/>
+                      </a:solidFill>
+                      <a:prstDash val="solid"/>
+                      <a:round/>
+                      <a:headEnd type="none" w="med" len="med"/>
+                      <a:tailEnd type="none" w="med" len="med"/>
+                    </a:lnR>
+                    <a:lnT w="6350" cap="flat" cmpd="sng" algn="ctr">
+                      <a:solidFill>
+                        <a:srgbClr val="DDE3EA"/>
+                      </a:solidFill>
+                      <a:prstDash val="solid"/>
+                      <a:round/>
+                      <a:headEnd type="none" w="med" len="med"/>
+                      <a:tailEnd type="none" w="med" len="med"/>
+                    </a:lnT>
+                    <a:lnB w="6350" cap="flat" cmpd="sng" algn="ctr">
+                      <a:solidFill>
+                        <a:srgbClr val="DDE3EA"/>
+                      </a:solidFill>
+                      <a:prstDash val="solid"/>
+                      <a:round/>
+                      <a:headEnd type="none" w="med" len="med"/>
+                      <a:tailEnd type="none" w="med" len="med"/>
+                    </a:lnB>
+                    <a:solidFill>
+                      <a:srgbClr val="EEF2F6"/>
+                    </a:solidFill>
+                  </a:tcPr>
+                </a:tc>
+              </a:tr>
+              <a:tr h="566928">
+                <a:tc>
+                  <a:txBody>
+                    <a:bodyPr/>
+                    <a:lstStyle/>
+                    <a:p>
+                      <a:pPr indent="0" marL="0">
+                        <a:buNone/>
+                      </a:pPr>
+                      <a:r>
+                        <a:rPr lang="en-US" sz="1400" b="1" dirty="0">
+                          <a:solidFill>
+                            <a:srgbClr val="1B2A41"/>
+                          </a:solidFill>
+                          <a:latin typeface="Calibri" pitchFamily="34" charset="0"/>
+                          <a:ea typeface="Calibri" pitchFamily="34" charset="-122"/>
+                          <a:cs typeface="Calibri" pitchFamily="34" charset="-120"/>
+                        </a:rPr>
+                        <a:t>Go/No-Go 26.4</a:t>
+                      </a:r>
+                      <a:endParaRPr lang="en-US" sz="1400" dirty="0">
+                        <a:latin typeface="Calibri" charset="0"/>
+                        <a:ea typeface="Calibri" charset="0"/>
+                        <a:cs typeface="Calibri" charset="0"/>
+                      </a:endParaRPr>
+                    </a:p>
+                  </a:txBody>
+                  <a:tcPr marL="91440" marR="91440" marT="45720" marB="45720" anchor="ctr">
+                    <a:lnL w="6350" cap="flat" cmpd="sng" algn="ctr">
+                      <a:solidFill>
+                        <a:srgbClr val="DDE3EA"/>
+                      </a:solidFill>
+                      <a:prstDash val="solid"/>
+                      <a:round/>
+                      <a:headEnd type="none" w="med" len="med"/>
+                      <a:tailEnd type="none" w="med" len="med"/>
+                    </a:lnL>
+                    <a:lnR w="6350" cap="flat" cmpd="sng" algn="ctr">
+                      <a:solidFill>
+                        <a:srgbClr val="DDE3EA"/>
+                      </a:solidFill>
+                      <a:prstDash val="solid"/>
+                      <a:round/>
+                      <a:headEnd type="none" w="med" len="med"/>
+                      <a:tailEnd type="none" w="med" len="med"/>
+                    </a:lnR>
+                    <a:lnT w="6350" cap="flat" cmpd="sng" algn="ctr">
+                      <a:solidFill>
+                        <a:srgbClr val="DDE3EA"/>
+                      </a:solidFill>
+                      <a:prstDash val="solid"/>
+                      <a:round/>
+                      <a:headEnd type="none" w="med" len="med"/>
+                      <a:tailEnd type="none" w="med" len="med"/>
+                    </a:lnT>
+                    <a:lnB w="6350" cap="flat" cmpd="sng" algn="ctr">
+                      <a:solidFill>
+                        <a:srgbClr val="DDE3EA"/>
+                      </a:solidFill>
+                      <a:prstDash val="solid"/>
+                      <a:round/>
+                      <a:headEnd type="none" w="med" len="med"/>
+                      <a:tailEnd type="none" w="med" len="med"/>
+                    </a:lnB>
+                    <a:solidFill>
+                      <a:srgbClr val="FFFFFF"/>
+                    </a:solidFill>
+                  </a:tcPr>
+                </a:tc>
+                <a:tc>
+                  <a:txBody>
+                    <a:bodyPr/>
+                    <a:lstStyle/>
+                    <a:p>
+                      <a:pPr indent="0" marL="0">
+                        <a:buNone/>
+                      </a:pPr>
+                      <a:r>
+                        <a:rPr lang="en-US" sz="1400" dirty="0">
+                          <a:solidFill>
+                            <a:srgbClr val="1B2A41"/>
+                          </a:solidFill>
+                          <a:latin typeface="Calibri" pitchFamily="34" charset="0"/>
+                          <a:ea typeface="Calibri" pitchFamily="34" charset="-122"/>
+                          <a:cs typeface="Calibri" pitchFamily="34" charset="-120"/>
+                        </a:rPr>
+                        <a:t>Master TBD; Orchestration Core conditional; most domains TBD</a:t>
+                      </a:r>
+                      <a:endParaRPr lang="en-US" sz="1400" dirty="0">
+                        <a:latin typeface="Calibri" charset="0"/>
+                        <a:ea typeface="Calibri" charset="0"/>
+                        <a:cs typeface="Calibri" charset="0"/>
+                      </a:endParaRPr>
+                    </a:p>
+                  </a:txBody>
+                  <a:tcPr marL="91440" marR="91440" marT="45720" marB="45720" anchor="ctr">
+                    <a:lnL w="6350" cap="flat" cmpd="sng" algn="ctr">
+                      <a:solidFill>
+                        <a:srgbClr val="DDE3EA"/>
+                      </a:solidFill>
+                      <a:prstDash val="solid"/>
+                      <a:round/>
+                      <a:headEnd type="none" w="med" len="med"/>
+                      <a:tailEnd type="none" w="med" len="med"/>
+                    </a:lnL>
+                    <a:lnR w="6350" cap="flat" cmpd="sng" algn="ctr">
+                      <a:solidFill>
+                        <a:srgbClr val="DDE3EA"/>
+                      </a:solidFill>
+                      <a:prstDash val="solid"/>
+                      <a:round/>
+                      <a:headEnd type="none" w="med" len="med"/>
+                      <a:tailEnd type="none" w="med" len="med"/>
+                    </a:lnR>
+                    <a:lnT w="6350" cap="flat" cmpd="sng" algn="ctr">
+                      <a:solidFill>
+                        <a:srgbClr val="DDE3EA"/>
+                      </a:solidFill>
+                      <a:prstDash val="solid"/>
+                      <a:round/>
+                      <a:headEnd type="none" w="med" len="med"/>
+                      <a:tailEnd type="none" w="med" len="med"/>
+                    </a:lnT>
+                    <a:lnB w="6350" cap="flat" cmpd="sng" algn="ctr">
+                      <a:solidFill>
+                        <a:srgbClr val="DDE3EA"/>
+                      </a:solidFill>
+                      <a:prstDash val="solid"/>
+                      <a:round/>
+                      <a:headEnd type="none" w="med" len="med"/>
+                      <a:tailEnd type="none" w="med" len="med"/>
+                    </a:lnB>
+                    <a:solidFill>
+                      <a:srgbClr val="FFFFFF"/>
+                    </a:solidFill>
+                  </a:tcPr>
+                </a:tc>
+                <a:tc>
+                  <a:txBody>
+                    <a:bodyPr/>
+                    <a:lstStyle/>
+                    <a:p>
+                      <a:pPr indent="0" marL="0">
+                        <a:buNone/>
+                      </a:pPr>
+                      <a:r>
+                        <a:rPr lang="en-US" sz="1400" dirty="0">
+                          <a:solidFill>
+                            <a:srgbClr val="1B2A41"/>
+                          </a:solidFill>
+                          <a:latin typeface="Calibri" pitchFamily="34" charset="0"/>
+                          <a:ea typeface="Calibri" pitchFamily="34" charset="-122"/>
+                          <a:cs typeface="Calibri" pitchFamily="34" charset="-120"/>
+                        </a:rPr>
+                        <a:t>Human</a:t>
+                      </a:r>
+                      <a:endParaRPr lang="en-US" sz="1400" dirty="0">
+                        <a:latin typeface="Calibri" charset="0"/>
+                        <a:ea typeface="Calibri" charset="0"/>
+                        <a:cs typeface="Calibri" charset="0"/>
+                      </a:endParaRPr>
+                    </a:p>
+                  </a:txBody>
+                  <a:tcPr marL="91440" marR="91440" marT="45720" marB="45720" anchor="ctr">
+                    <a:lnL w="6350" cap="flat" cmpd="sng" algn="ctr">
+                      <a:solidFill>
+                        <a:srgbClr val="DDE3EA"/>
+                      </a:solidFill>
+                      <a:prstDash val="solid"/>
+                      <a:round/>
+                      <a:headEnd type="none" w="med" len="med"/>
+                      <a:tailEnd type="none" w="med" len="med"/>
+                    </a:lnL>
+                    <a:lnR w="6350" cap="flat" cmpd="sng" algn="ctr">
+                      <a:solidFill>
+                        <a:srgbClr val="DDE3EA"/>
+                      </a:solidFill>
+                      <a:prstDash val="solid"/>
+                      <a:round/>
+                      <a:headEnd type="none" w="med" len="med"/>
+                      <a:tailEnd type="none" w="med" len="med"/>
+                    </a:lnR>
+                    <a:lnT w="6350" cap="flat" cmpd="sng" algn="ctr">
+                      <a:solidFill>
+                        <a:srgbClr val="DDE3EA"/>
+                      </a:solidFill>
+                      <a:prstDash val="solid"/>
+                      <a:round/>
+                      <a:headEnd type="none" w="med" len="med"/>
+                      <a:tailEnd type="none" w="med" len="med"/>
+                    </a:lnT>
+                    <a:lnB w="6350" cap="flat" cmpd="sng" algn="ctr">
+                      <a:solidFill>
+                        <a:srgbClr val="DDE3EA"/>
+                      </a:solidFill>
+                      <a:prstDash val="solid"/>
+                      <a:round/>
+                      <a:headEnd type="none" w="med" len="med"/>
+                      <a:tailEnd type="none" w="med" len="med"/>
+                    </a:lnB>
+                    <a:solidFill>
+                      <a:srgbClr val="FFFFFF"/>
+                    </a:solidFill>
+                  </a:tcPr>
+                </a:tc>
+              </a:tr>
+              <a:tr h="566928">
+                <a:tc>
+                  <a:txBody>
+                    <a:bodyPr/>
+                    <a:lstStyle/>
+                    <a:p>
+                      <a:pPr indent="0" marL="0">
+                        <a:buNone/>
+                      </a:pPr>
+                      <a:r>
+                        <a:rPr lang="en-US" sz="1400" b="1" dirty="0">
+                          <a:solidFill>
+                            <a:srgbClr val="1B2A41"/>
+                          </a:solidFill>
+                          <a:latin typeface="Calibri" pitchFamily="34" charset="0"/>
+                          <a:ea typeface="Calibri" pitchFamily="34" charset="-122"/>
+                          <a:cs typeface="Calibri" pitchFamily="34" charset="-120"/>
+                        </a:rPr>
+                        <a:t>Mutation testing</a:t>
+                      </a:r>
+                      <a:endParaRPr lang="en-US" sz="1400" dirty="0">
+                        <a:latin typeface="Calibri" charset="0"/>
+                        <a:ea typeface="Calibri" charset="0"/>
+                        <a:cs typeface="Calibri" charset="0"/>
+                      </a:endParaRPr>
+                    </a:p>
+                  </a:txBody>
+                  <a:tcPr marL="91440" marR="91440" marT="45720" marB="45720" anchor="ctr">
+                    <a:lnL w="6350" cap="flat" cmpd="sng" algn="ctr">
+                      <a:solidFill>
+                        <a:srgbClr val="DDE3EA"/>
+                      </a:solidFill>
+                      <a:prstDash val="solid"/>
+                      <a:round/>
+                      <a:headEnd type="none" w="med" len="med"/>
+                      <a:tailEnd type="none" w="med" len="med"/>
+                    </a:lnL>
+                    <a:lnR w="6350" cap="flat" cmpd="sng" algn="ctr">
+                      <a:solidFill>
+                        <a:srgbClr val="DDE3EA"/>
+                      </a:solidFill>
+                      <a:prstDash val="solid"/>
+                      <a:round/>
+                      <a:headEnd type="none" w="med" len="med"/>
+                      <a:tailEnd type="none" w="med" len="med"/>
+                    </a:lnR>
+                    <a:lnT w="6350" cap="flat" cmpd="sng" algn="ctr">
+                      <a:solidFill>
+                        <a:srgbClr val="DDE3EA"/>
+                      </a:solidFill>
+                      <a:prstDash val="solid"/>
+                      <a:round/>
+                      <a:headEnd type="none" w="med" len="med"/>
+                      <a:tailEnd type="none" w="med" len="med"/>
+                    </a:lnT>
+                    <a:lnB w="6350" cap="flat" cmpd="sng" algn="ctr">
+                      <a:solidFill>
+                        <a:srgbClr val="DDE3EA"/>
+                      </a:solidFill>
+                      <a:prstDash val="solid"/>
+                      <a:round/>
+                      <a:headEnd type="none" w="med" len="med"/>
+                      <a:tailEnd type="none" w="med" len="med"/>
+                    </a:lnB>
+                    <a:solidFill>
+                      <a:srgbClr val="EEF2F6"/>
+                    </a:solidFill>
+                  </a:tcPr>
+                </a:tc>
+                <a:tc>
+                  <a:txBody>
+                    <a:bodyPr/>
+                    <a:lstStyle/>
+                    <a:p>
+                      <a:pPr indent="0" marL="0">
+                        <a:buNone/>
+                      </a:pPr>
+                      <a:r>
+                        <a:rPr lang="en-US" sz="1400" dirty="0">
+                          <a:solidFill>
+                            <a:srgbClr val="1B2A41"/>
+                          </a:solidFill>
+                          <a:latin typeface="Calibri" pitchFamily="34" charset="0"/>
+                          <a:ea typeface="Calibri" pitchFamily="34" charset="-122"/>
+                          <a:cs typeface="Calibri" pitchFamily="34" charset="-120"/>
+                        </a:rPr>
+                        <a:t>Pilot done; company-wide by end of Nov</a:t>
+                      </a:r>
+                      <a:endParaRPr lang="en-US" sz="1400" dirty="0">
+                        <a:latin typeface="Calibri" charset="0"/>
+                        <a:ea typeface="Calibri" charset="0"/>
+                        <a:cs typeface="Calibri" charset="0"/>
+                      </a:endParaRPr>
+                    </a:p>
+                  </a:txBody>
+                  <a:tcPr marL="91440" marR="91440" marT="45720" marB="45720" anchor="ctr">
+                    <a:lnL w="6350" cap="flat" cmpd="sng" algn="ctr">
+                      <a:solidFill>
+                        <a:srgbClr val="DDE3EA"/>
+                      </a:solidFill>
+                      <a:prstDash val="solid"/>
+                      <a:round/>
+                      <a:headEnd type="none" w="med" len="med"/>
+                      <a:tailEnd type="none" w="med" len="med"/>
+                    </a:lnL>
+                    <a:lnR w="6350" cap="flat" cmpd="sng" algn="ctr">
+                      <a:solidFill>
+                        <a:srgbClr val="DDE3EA"/>
+                      </a:solidFill>
+                      <a:prstDash val="solid"/>
+                      <a:round/>
+                      <a:headEnd type="none" w="med" len="med"/>
+                      <a:tailEnd type="none" w="med" len="med"/>
+                    </a:lnR>
+                    <a:lnT w="6350" cap="flat" cmpd="sng" algn="ctr">
+                      <a:solidFill>
+                        <a:srgbClr val="DDE3EA"/>
+                      </a:solidFill>
+                      <a:prstDash val="solid"/>
+                      <a:round/>
+                      <a:headEnd type="none" w="med" len="med"/>
+                      <a:tailEnd type="none" w="med" len="med"/>
+                    </a:lnT>
+                    <a:lnB w="6350" cap="flat" cmpd="sng" algn="ctr">
+                      <a:solidFill>
+                        <a:srgbClr val="DDE3EA"/>
+                      </a:solidFill>
+                      <a:prstDash val="solid"/>
+                      <a:round/>
+                      <a:headEnd type="none" w="med" len="med"/>
+                      <a:tailEnd type="none" w="med" len="med"/>
+                    </a:lnB>
+                    <a:solidFill>
+                      <a:srgbClr val="EEF2F6"/>
+                    </a:solidFill>
+                  </a:tcPr>
+                </a:tc>
+                <a:tc>
+                  <a:txBody>
+                    <a:bodyPr/>
+                    <a:lstStyle/>
+                    <a:p>
+                      <a:pPr indent="0" marL="0">
+                        <a:buNone/>
+                      </a:pPr>
+                      <a:r>
+                        <a:rPr lang="en-US" sz="1400" dirty="0">
+                          <a:solidFill>
+                            <a:srgbClr val="1B2A41"/>
+                          </a:solidFill>
+                          <a:latin typeface="Calibri" pitchFamily="34" charset="0"/>
+                          <a:ea typeface="Calibri" pitchFamily="34" charset="-122"/>
+                          <a:cs typeface="Calibri" pitchFamily="34" charset="-120"/>
+                        </a:rPr>
+                        <a:t>From Dec 15 (plan)</a:t>
+                      </a:r>
+                      <a:endParaRPr lang="en-US" sz="1400" dirty="0">
+                        <a:latin typeface="Calibri" charset="0"/>
+                        <a:ea typeface="Calibri" charset="0"/>
+                        <a:cs typeface="Calibri" charset="0"/>
+                      </a:endParaRPr>
+                    </a:p>
+                  </a:txBody>
+                  <a:tcPr marL="91440" marR="91440" marT="45720" marB="45720" anchor="ctr">
+                    <a:lnL w="6350" cap="flat" cmpd="sng" algn="ctr">
+                      <a:solidFill>
+                        <a:srgbClr val="DDE3EA"/>
+                      </a:solidFill>
+                      <a:prstDash val="solid"/>
+                      <a:round/>
+                      <a:headEnd type="none" w="med" len="med"/>
+                      <a:tailEnd type="none" w="med" len="med"/>
+                    </a:lnL>
+                    <a:lnR w="6350" cap="flat" cmpd="sng" algn="ctr">
+                      <a:solidFill>
+                        <a:srgbClr val="DDE3EA"/>
+                      </a:solidFill>
+                      <a:prstDash val="solid"/>
+                      <a:round/>
+                      <a:headEnd type="none" w="med" len="med"/>
+                      <a:tailEnd type="none" w="med" len="med"/>
+                    </a:lnR>
+                    <a:lnT w="6350" cap="flat" cmpd="sng" algn="ctr">
+                      <a:solidFill>
+                        <a:srgbClr val="DDE3EA"/>
+                      </a:solidFill>
+                      <a:prstDash val="solid"/>
+                      <a:round/>
+                      <a:headEnd type="none" w="med" len="med"/>
+                      <a:tailEnd type="none" w="med" len="med"/>
+                    </a:lnT>
+                    <a:lnB w="6350" cap="flat" cmpd="sng" algn="ctr">
+                      <a:solidFill>
+                        <a:srgbClr val="DDE3EA"/>
+                      </a:solidFill>
+                      <a:prstDash val="solid"/>
+                      <a:round/>
+                      <a:headEnd type="none" w="med" len="med"/>
+                      <a:tailEnd type="none" w="med" len="med"/>
+                    </a:lnB>
+                    <a:solidFill>
+                      <a:srgbClr val="EEF2F6"/>
+                    </a:solidFill>
+                  </a:tcPr>
+                </a:tc>
+              </a:tr>
+              <a:tr h="566928">
+                <a:tc>
+                  <a:txBody>
+                    <a:bodyPr/>
+                    <a:lstStyle/>
+                    <a:p>
+                      <a:pPr indent="0" marL="0">
+                        <a:buNone/>
+                      </a:pPr>
+                      <a:r>
+                        <a:rPr lang="en-US" sz="1400" b="1" dirty="0">
+                          <a:solidFill>
+                            <a:srgbClr val="1B2A41"/>
+                          </a:solidFill>
+                          <a:latin typeface="Calibri" pitchFamily="34" charset="0"/>
+                          <a:ea typeface="Calibri" pitchFamily="34" charset="-122"/>
+                          <a:cs typeface="Calibri" pitchFamily="34" charset="-120"/>
+                        </a:rPr>
+                        <a:t>RIA, RCA, Jira quality fields</a:t>
+                      </a:r>
+                      <a:endParaRPr lang="en-US" sz="1400" dirty="0">
+                        <a:latin typeface="Calibri" charset="0"/>
+                        <a:ea typeface="Calibri" charset="0"/>
+                        <a:cs typeface="Calibri" charset="0"/>
+                      </a:endParaRPr>
+                    </a:p>
+                  </a:txBody>
+                  <a:tcPr marL="91440" marR="91440" marT="45720" marB="45720" anchor="ctr">
+                    <a:lnL w="6350" cap="flat" cmpd="sng" algn="ctr">
+                      <a:solidFill>
+                        <a:srgbClr val="DDE3EA"/>
+                      </a:solidFill>
+                      <a:prstDash val="solid"/>
+                      <a:round/>
+                      <a:headEnd type="none" w="med" len="med"/>
+                      <a:tailEnd type="none" w="med" len="med"/>
+                    </a:lnL>
+                    <a:lnR w="6350" cap="flat" cmpd="sng" algn="ctr">
+                      <a:solidFill>
+                        <a:srgbClr val="DDE3EA"/>
+                      </a:solidFill>
+                      <a:prstDash val="solid"/>
+                      <a:round/>
+                      <a:headEnd type="none" w="med" len="med"/>
+                      <a:tailEnd type="none" w="med" len="med"/>
+                    </a:lnR>
+                    <a:lnT w="6350" cap="flat" cmpd="sng" algn="ctr">
+                      <a:solidFill>
+                        <a:srgbClr val="DDE3EA"/>
+                      </a:solidFill>
+                      <a:prstDash val="solid"/>
+                      <a:round/>
+                      <a:headEnd type="none" w="med" len="med"/>
+                      <a:tailEnd type="none" w="med" len="med"/>
+                    </a:lnT>
+                    <a:lnB w="6350" cap="flat" cmpd="sng" algn="ctr">
+                      <a:solidFill>
+                        <a:srgbClr val="DDE3EA"/>
+                      </a:solidFill>
+                      <a:prstDash val="solid"/>
+                      <a:round/>
+                      <a:headEnd type="none" w="med" len="med"/>
+                      <a:tailEnd type="none" w="med" len="med"/>
+                    </a:lnB>
+                    <a:solidFill>
+                      <a:srgbClr val="FFFFFF"/>
+                    </a:solidFill>
+                  </a:tcPr>
+                </a:tc>
+                <a:tc>
+                  <a:txBody>
+                    <a:bodyPr/>
+                    <a:lstStyle/>
+                    <a:p>
+                      <a:pPr indent="0" marL="0">
+                        <a:buNone/>
+                      </a:pPr>
+                      <a:r>
+                        <a:rPr lang="en-US" sz="1400" dirty="0">
+                          <a:solidFill>
+                            <a:srgbClr val="1B2A41"/>
+                          </a:solidFill>
+                          <a:latin typeface="Calibri" pitchFamily="34" charset="0"/>
+                          <a:ea typeface="Calibri" pitchFamily="34" charset="-122"/>
+                          <a:cs typeface="Calibri" pitchFamily="34" charset="-120"/>
+                        </a:rPr>
+                        <a:t>Fields filled by policy; not enforced</a:t>
+                      </a:r>
+                      <a:endParaRPr lang="en-US" sz="1400" dirty="0">
+                        <a:latin typeface="Calibri" charset="0"/>
+                        <a:ea typeface="Calibri" charset="0"/>
+                        <a:cs typeface="Calibri" charset="0"/>
+                      </a:endParaRPr>
+                    </a:p>
+                  </a:txBody>
+                  <a:tcPr marL="91440" marR="91440" marT="45720" marB="45720" anchor="ctr">
+                    <a:lnL w="6350" cap="flat" cmpd="sng" algn="ctr">
+                      <a:solidFill>
+                        <a:srgbClr val="DDE3EA"/>
+                      </a:solidFill>
+                      <a:prstDash val="solid"/>
+                      <a:round/>
+                      <a:headEnd type="none" w="med" len="med"/>
+                      <a:tailEnd type="none" w="med" len="med"/>
+                    </a:lnL>
+                    <a:lnR w="6350" cap="flat" cmpd="sng" algn="ctr">
+                      <a:solidFill>
+                        <a:srgbClr val="DDE3EA"/>
+                      </a:solidFill>
+                      <a:prstDash val="solid"/>
+                      <a:round/>
+                      <a:headEnd type="none" w="med" len="med"/>
+                      <a:tailEnd type="none" w="med" len="med"/>
+                    </a:lnR>
+                    <a:lnT w="6350" cap="flat" cmpd="sng" algn="ctr">
+                      <a:solidFill>
+                        <a:srgbClr val="DDE3EA"/>
+                      </a:solidFill>
+                      <a:prstDash val="solid"/>
+                      <a:round/>
+                      <a:headEnd type="none" w="med" len="med"/>
+                      <a:tailEnd type="none" w="med" len="med"/>
+                    </a:lnT>
+                    <a:lnB w="6350" cap="flat" cmpd="sng" algn="ctr">
+                      <a:solidFill>
+                        <a:srgbClr val="DDE3EA"/>
+                      </a:solidFill>
+                      <a:prstDash val="solid"/>
+                      <a:round/>
+                      <a:headEnd type="none" w="med" len="med"/>
+                      <a:tailEnd type="none" w="med" len="med"/>
+                    </a:lnB>
+                    <a:solidFill>
+                      <a:srgbClr val="FFFFFF"/>
+                    </a:solidFill>
+                  </a:tcPr>
+                </a:tc>
+                <a:tc>
+                  <a:txBody>
+                    <a:bodyPr/>
+                    <a:lstStyle/>
+                    <a:p>
+                      <a:pPr indent="0" marL="0">
+                        <a:buNone/>
+                      </a:pPr>
+                      <a:r>
+                        <a:rPr lang="en-US" sz="1400" dirty="0">
+                          <a:solidFill>
+                            <a:srgbClr val="C8443D"/>
+                          </a:solidFill>
+                          <a:latin typeface="Calibri" pitchFamily="34" charset="0"/>
+                          <a:ea typeface="Calibri" pitchFamily="34" charset="-122"/>
+                          <a:cs typeface="Calibri" pitchFamily="34" charset="-120"/>
+                        </a:rPr>
+                        <a:t>No</a:t>
+                      </a:r>
+                      <a:endParaRPr lang="en-US" sz="1400" dirty="0">
+                        <a:latin typeface="Calibri" charset="0"/>
+                        <a:ea typeface="Calibri" charset="0"/>
+                        <a:cs typeface="Calibri" charset="0"/>
+                      </a:endParaRPr>
+                    </a:p>
+                  </a:txBody>
+                  <a:tcPr marL="91440" marR="91440" marT="45720" marB="45720" anchor="ctr">
+                    <a:lnL w="6350" cap="flat" cmpd="sng" algn="ctr">
+                      <a:solidFill>
+                        <a:srgbClr val="DDE3EA"/>
+                      </a:solidFill>
+                      <a:prstDash val="solid"/>
+                      <a:round/>
+                      <a:headEnd type="none" w="med" len="med"/>
+                      <a:tailEnd type="none" w="med" len="med"/>
+                    </a:lnL>
+                    <a:lnR w="6350" cap="flat" cmpd="sng" algn="ctr">
+                      <a:solidFill>
+                        <a:srgbClr val="DDE3EA"/>
+                      </a:solidFill>
+                      <a:prstDash val="solid"/>
+                      <a:round/>
+                      <a:headEnd type="none" w="med" len="med"/>
+                      <a:tailEnd type="none" w="med" len="med"/>
+                    </a:lnR>
+                    <a:lnT w="6350" cap="flat" cmpd="sng" algn="ctr">
+                      <a:solidFill>
+                        <a:srgbClr val="DDE3EA"/>
+                      </a:solidFill>
+                      <a:prstDash val="solid"/>
+                      <a:round/>
+                      <a:headEnd type="none" w="med" len="med"/>
+                      <a:tailEnd type="none" w="med" len="med"/>
+                    </a:lnT>
+                    <a:lnB w="6350" cap="flat" cmpd="sng" algn="ctr">
+                      <a:solidFill>
+                        <a:srgbClr val="DDE3EA"/>
+                      </a:solidFill>
+                      <a:prstDash val="solid"/>
+                      <a:round/>
+                      <a:headEnd type="none" w="med" len="med"/>
+                      <a:tailEnd type="none" w="med" len="med"/>
+                    </a:lnB>
+                    <a:solidFill>
+                      <a:srgbClr val="FFFFFF"/>
+                    </a:solidFill>
+                  </a:tcPr>
+                </a:tc>
+              </a:tr>
+            </a:tbl>
+          </a:graphicData>
+        </a:graphic>
+      </p:graphicFrame>
+      <p:sp>
+        <p:nvSpPr>
+          <p:cNvPr id="4" name="mut-card"/>
+          <p:cNvSpPr/>
+          <p:nvPr/>
+        </p:nvSpPr>
+        <p:spPr>
+          <a:xfrm>
+            <a:off x="7863840" y="1371600"/>
+            <a:ext cx="3749040" cy="3611880"/>
+          </a:xfrm>
+          <a:prstGeom prst="roundRect">
+            <a:avLst>
+              <a:gd name="adj" fmla="val 2025"/>
+            </a:avLst>
+          </a:prstGeom>
+          <a:solidFill>
+            <a:schemeClr val="bg2"/>
+          </a:solidFill>
+          <a:ln w="12700">
+            <a:solidFill>
+              <a:schemeClr val="bg2"/>
+            </a:solidFill>
+            <a:prstDash val="solid"/>
+          </a:ln>
+        </p:spPr>
+      </p:sp>
+      <p:sp>
+        <p:nvSpPr>
+          <p:cNvPr id="5" name="Text 2"/>
+          <p:cNvSpPr txBox="1"/>
+          <p:nvPr/>
+        </p:nvSpPr>
+        <p:spPr>
+          <a:xfrm>
+            <a:off x="8092440" y="1554480"/>
+            <a:ext cx="3291840" cy="411480"/>
+          </a:xfrm>
+          <a:prstGeom prst="rect">
+            <a:avLst/>
+          </a:prstGeom>
+          <a:noFill/>
+          <a:ln/>
+        </p:spPr>
+        <p:txBody>
+          <a:bodyPr wrap="square" lIns="0" tIns="0" rIns="0" bIns="0" rtlCol="0" anchor="t"/>
+          <a:lstStyle/>
+          <a:p>
+            <a:pPr indent="0" marL="0">
+              <a:buNone/>
+            </a:pPr>
+            <a:r>
+              <a:rPr lang="en-US" sz="1700" b="1" dirty="0">
+                <a:solidFill>
+                  <a:schemeClr val="tx1"/>
+                </a:solidFill>
+              </a:rPr>
+              <a:t>Mutation gate on Dec 15</a:t>
+            </a:r>
+            <a:endParaRPr lang="en-US" sz="1700" dirty="0"/>
+          </a:p>
+        </p:txBody>
+      </p:sp>
+      <p:sp>
+        <p:nvSpPr>
+          <p:cNvPr id="6" name="Text 3"/>
+          <p:cNvSpPr txBox="1"/>
+          <p:nvPr/>
+        </p:nvSpPr>
+        <p:spPr>
+          <a:xfrm>
+            <a:off x="8092440" y="2011680"/>
+            <a:ext cx="3291840" cy="2880360"/>
+          </a:xfrm>
+          <a:prstGeom prst="rect">
+            <a:avLst/>
+          </a:prstGeom>
+          <a:noFill/>
+          <a:ln/>
+        </p:spPr>
+        <p:txBody>
+          <a:bodyPr wrap="square" lIns="0" tIns="0" rIns="0" bIns="0" rtlCol="0" anchor="t"/>
+          <a:lstStyle/>
+          <a:p>
+            <a:pPr indent="0" marL="0">
+              <a:spcAft>
+                <a:spcPts val="400"/>
+              </a:spcAft>
+              <a:buNone/>
+            </a:pPr>
+            <a:r>
+              <a:rPr lang="en-US" sz="3000" b="1" dirty="0">
+                <a:solidFill>
+                  <a:srgbClr val="C8443D"/>
+                </a:solidFill>
+              </a:rPr>
+              <a:t>3%</a:t>
+            </a:r>
+            <a:endParaRPr lang="en-US" sz="1500" dirty="0"/>
+          </a:p>
+          <a:p>
+            <a:pPr indent="0" marL="0">
+              <a:spcAft>
+                <a:spcPts val="400"/>
+              </a:spcAft>
+              <a:buNone/>
+            </a:pPr>
+            <a:r>
+              <a:rPr lang="en-US" sz="1500" dirty="0">
+                <a:solidFill>
+                  <a:schemeClr val="tx1"/>
+                </a:solidFill>
+              </a:rPr>
+              <a:t>of escapes come from weak tests</a:t>
+            </a:r>
+            <a:endParaRPr lang="en-US" sz="1500" dirty="0"/>
+          </a:p>
+          <a:p>
+            <a:pPr indent="0" marL="0">
+              <a:spcAft>
+                <a:spcPts val="400"/>
+              </a:spcAft>
+              <a:buNone/>
+            </a:pPr>
+            <a:r>
+              <a:rPr lang="en-US" sz="3000" b="1" dirty="0">
+                <a:solidFill>
+                  <a:srgbClr val="C8443D"/>
+                </a:solidFill>
+              </a:rPr>
+              <a:t>2 of 4</a:t>
+            </a:r>
+            <a:endParaRPr lang="en-US" sz="1500" dirty="0"/>
+          </a:p>
+          <a:p>
+            <a:pPr indent="0" marL="0">
+              <a:spcAft>
+                <a:spcPts val="400"/>
+              </a:spcAft>
+              <a:buNone/>
+            </a:pPr>
+            <a:r>
+              <a:rPr lang="en-US" sz="1500" dirty="0">
+                <a:solidFill>
+                  <a:schemeClr val="tx1"/>
+                </a:solidFill>
+              </a:rPr>
+              <a:t>pilot fails were false (timeouts, compile errors)</a:t>
+            </a:r>
+            <a:endParaRPr lang="en-US" sz="1500" dirty="0"/>
+          </a:p>
+          <a:p>
+            <a:pPr indent="0" marL="0">
+              <a:spcAft>
+                <a:spcPts val="400"/>
+              </a:spcAft>
+              <a:buNone/>
+            </a:pPr>
+            <a:r>
+              <a:rPr lang="en-US" sz="1500" b="1" dirty="0">
+                <a:solidFill>
+                  <a:srgbClr val="2A8C82"/>
+                </a:solidFill>
+              </a:rPr>
+              <a:t>Recommendation</a:t>
+            </a:r>
+            <a:endParaRPr lang="en-US" sz="1500" dirty="0"/>
+          </a:p>
+          <a:p>
+            <a:pPr indent="0" marL="0">
+              <a:spcAft>
+                <a:spcPts val="400"/>
+              </a:spcAft>
+              <a:buNone/>
+            </a:pPr>
+            <a:r>
+              <a:rPr lang="en-US" sz="1500" dirty="0">
+                <a:solidFill>
+                  <a:schemeClr val="tx1"/>
+                </a:solidFill>
+              </a:rPr>
+              <a:t>Show the score in Sonar now. Block per scope only after fixes, data, and a risk-based scope.</a:t>
+            </a:r>
+            <a:endParaRPr lang="en-US" sz="1500" dirty="0"/>
+          </a:p>
+        </p:txBody>
+      </p:sp>
+      <p:sp>
+        <p:nvSpPr>
+          <p:cNvPr id="25" name="Slide Number Placeholder 0"/>
+          <p:cNvSpPr>
+            <a:spLocks noGrp="1"/>
+          </p:cNvSpPr>
+          <p:nvPr>
+            <p:ph type="sldNum" sz="quarter" idx="4294967295"/>
+          </p:nvPr>
+        </p:nvSpPr>
+        <p:spPr>
+          <a:xfrm>
+            <a:off x="11247120" y="6400800"/>
+            <a:ext cx="457200" cy="274320"/>
+          </a:xfrm>
+          <a:prstGeom prst="rect">
+            <a:avLst/>
+          </a:prstGeom>
+          <a:extLst>
+            <a:ext uri="{C572A759-6A51-4108-AA02-DFA0A04FC94B}">
+              <ma14:wrappingTextBoxFlag xmlns:ma14="http://schemas.microsoft.com/office/mac/drawingml/2011/main" val="0"/>
+            </a:ext>
+          </a:extLst>
+        </p:spPr>
+        <p:txBody>
+          <a:bodyPr/>
+          <a:lstStyle>
+            <a:lvl1pPr>
+              <a:defRPr sz="1000">
+                <a:solidFill>
+                  <a:schemeClr val="tx2"/>
+                </a:solidFill>
+              </a:defRPr>
+            </a:lvl1pPr>
+          </a:lstStyle>
+          <a:p>
+            <a:pPr algn="r"/>
+            <a:fld id="{F7021451-1387-4CA6-816F-3879F97B5CBC}" type="slidenum">
+              <a:rPr b="0" lang="en-US"/>
+              <a:t>12</a:t>
+            </a:fld>
+            <a:endParaRPr lang="en-US"/>
+          </a:p>
+        </p:txBody>
+      </p:sp>
+    </p:spTree>
+  </p:cSld>
+  <p:clrMapOvr>
+    <a:masterClrMapping/>
+  </p:clrMapOvr>
+</p:sld>
+</file>
+
+<file path=ppt/slides/slide13.xml><?xml version="1.0" encoding="utf-8"?>
+<p:sld xmlns:a="http://schemas.openxmlformats.org/drawingml/2006/main" xmlns:r="http://schemas.openxmlformats.org/officeDocument/2006/relationships" xmlns:p="http://schemas.openxmlformats.org/presentationml/2006/main">
+  <p:cSld name="Slide 13">
+    <p:spTree>
+      <p:nvGrpSpPr>
+        <p:cNvPr id="1" name=""/>
+        <p:cNvGrpSpPr/>
+        <p:nvPr/>
+      </p:nvGrpSpPr>
+      <p:grpSpPr>
+        <a:xfrm>
+          <a:off x="0" y="0"/>
+          <a:ext cx="0" cy="0"/>
+          <a:chOff x="0" y="0"/>
+          <a:chExt cx="0" cy="0"/>
+        </a:xfrm>
+      </p:grpSpPr>
+      <p:sp>
+        <p:nvSpPr>
+          <p:cNvPr id="2" name="Text 0"/>
+          <p:cNvSpPr/>
+          <p:nvPr>
+            <p:ph idx="100" type="title" hasCustomPrompt="1"/>
+          </p:nvPr>
+        </p:nvSpPr>
+        <p:spPr>
+          <a:xfrm>
+            <a:off x="548640" y="320040"/>
+            <a:ext cx="11064240" cy="868680"/>
+          </a:xfrm>
+          <a:prstGeom prst="rect">
+            <a:avLst/>
+          </a:prstGeom>
+          <a:noFill/>
+          <a:ln/>
+        </p:spPr>
+        <p:txBody>
+          <a:bodyPr wrap="square" lIns="0" tIns="0" rIns="0" bIns="0" rtlCol="0" anchor="ctr"/>
+          <a:lstStyle/>
+          <a:p>
+            <a:pPr algn="l" indent="0" marL="0">
+              <a:buNone/>
+            </a:pPr>
+            <a:r>
+              <a:rPr lang="en-US" sz="3000" b="1" dirty="0">
+                <a:solidFill>
+                  <a:schemeClr val="tx1"/>
+                </a:solidFill>
+              </a:rPr>
+              <a:t>Our gates and quality automation: means, not goals</a:t>
+            </a:r>
+            <a:endParaRPr lang="en-US" sz="3000" dirty="0"/>
+          </a:p>
+        </p:txBody>
+      </p:sp>
+      <p:graphicFrame>
+        <p:nvGraphicFramePr>
+          <p:cNvPr id="14" name="means-table"/>
           <p:cNvGraphicFramePr>
             <a:graphicFrameLocks noGrp="1"/>
           </p:cNvGraphicFramePr>
@@ -8252,7 +10110,7 @@
                           <a:ea typeface="Calibri" pitchFamily="34" charset="-122"/>
                           <a:cs typeface="Calibri" pitchFamily="34" charset="-120"/>
                         </a:rPr>
-                        <a:t>Later, only if X3/X4 show weak tests (weak tests = 3%)</a:t>
+                        <a:t>Dec 15 gate: show in Sonar, block only after fixes and evidence</a:t>
                       </a:r>
                       <a:endParaRPr lang="en-US" sz="1400" dirty="0">
                         <a:latin typeface="Calibri" charset="0"/>
@@ -8320,7 +10178,7 @@
                           <a:ea typeface="Calibri" pitchFamily="34" charset="-122"/>
                           <a:cs typeface="Calibri" pitchFamily="34" charset="-120"/>
                         </a:rPr>
-                        <a:t>H2 2027</a:t>
+                        <a:t>Dec 15 -&gt; 2027</a:t>
                       </a:r>
                       <a:endParaRPr lang="en-US" sz="1400" dirty="0">
                         <a:latin typeface="Calibri" charset="0"/>
@@ -8657,950 +10515,6 @@
             <a:pPr algn="r"/>
             <a:fld id="{F7021451-1387-4CA6-816F-3879F97B5CBC}" type="slidenum">
               <a:rPr b="0" lang="en-US"/>
-              <a:t>12</a:t>
-            </a:fld>
-            <a:endParaRPr lang="en-US"/>
-          </a:p>
-        </p:txBody>
-      </p:sp>
-    </p:spTree>
-  </p:cSld>
-  <p:clrMapOvr>
-    <a:masterClrMapping/>
-  </p:clrMapOvr>
-</p:sld>
-</file>
-
-<file path=ppt/slides/slide13.xml><?xml version="1.0" encoding="utf-8"?>
-<p:sld xmlns:a="http://schemas.openxmlformats.org/drawingml/2006/main" xmlns:r="http://schemas.openxmlformats.org/officeDocument/2006/relationships" xmlns:p="http://schemas.openxmlformats.org/presentationml/2006/main">
-  <p:cSld name="Slide 13">
-    <p:spTree>
-      <p:nvGrpSpPr>
-        <p:cNvPr id="1" name=""/>
-        <p:cNvGrpSpPr/>
-        <p:nvPr/>
-      </p:nvGrpSpPr>
-      <p:grpSpPr>
-        <a:xfrm>
-          <a:off x="0" y="0"/>
-          <a:ext cx="0" cy="0"/>
-          <a:chOff x="0" y="0"/>
-          <a:chExt cx="0" cy="0"/>
-        </a:xfrm>
-      </p:grpSpPr>
-      <p:sp>
-        <p:nvSpPr>
-          <p:cNvPr id="2" name="Text 0"/>
-          <p:cNvSpPr/>
-          <p:nvPr>
-            <p:ph idx="100" type="title" hasCustomPrompt="1"/>
-          </p:nvPr>
-        </p:nvSpPr>
-        <p:spPr>
-          <a:xfrm>
-            <a:off x="548640" y="320040"/>
-            <a:ext cx="11064240" cy="868680"/>
-          </a:xfrm>
-          <a:prstGeom prst="rect">
-            <a:avLst/>
-          </a:prstGeom>
-          <a:noFill/>
-          <a:ln/>
-        </p:spPr>
-        <p:txBody>
-          <a:bodyPr wrap="square" lIns="0" tIns="0" rIns="0" bIns="0" rtlCol="0" anchor="ctr"/>
-          <a:lstStyle/>
-          <a:p>
-            <a:pPr algn="l" indent="0" marL="0">
-              <a:buNone/>
-            </a:pPr>
-            <a:r>
-              <a:rPr lang="en-US" sz="3000" b="1" dirty="0">
-                <a:solidFill>
-                  <a:schemeClr val="tx1"/>
-                </a:solidFill>
-              </a:rPr>
-              <a:t>When: measure first, test in a few teams, then spread</a:t>
-            </a:r>
-            <a:endParaRPr lang="en-US" sz="3000" dirty="0"/>
-          </a:p>
-        </p:txBody>
-      </p:sp>
-      <p:sp>
-        <p:nvSpPr>
-          <p:cNvPr id="3" name="phase-0"/>
-          <p:cNvSpPr/>
-          <p:nvPr/>
-        </p:nvSpPr>
-        <p:spPr>
-          <a:xfrm>
-            <a:off x="548640" y="1371600"/>
-            <a:ext cx="2697480" cy="777240"/>
-          </a:xfrm>
-          <a:prstGeom prst="chevron">
-            <a:avLst/>
-          </a:prstGeom>
-          <a:solidFill>
-            <a:srgbClr val="C8443D"/>
-          </a:solidFill>
-          <a:ln w="12700">
-            <a:solidFill>
-              <a:srgbClr val="C8443D"/>
-            </a:solidFill>
-            <a:prstDash val="solid"/>
-          </a:ln>
-        </p:spPr>
-      </p:sp>
-      <p:sp>
-        <p:nvSpPr>
-          <p:cNvPr id="4" name="Text 2"/>
-          <p:cNvSpPr txBox="1"/>
-          <p:nvPr/>
-        </p:nvSpPr>
-        <p:spPr>
-          <a:xfrm>
-            <a:off x="822960" y="1371600"/>
-            <a:ext cx="2148840" cy="777240"/>
-          </a:xfrm>
-          <a:prstGeom prst="rect">
-            <a:avLst/>
-          </a:prstGeom>
-          <a:noFill/>
-          <a:ln/>
-        </p:spPr>
-        <p:txBody>
-          <a:bodyPr wrap="square" lIns="0" tIns="0" rIns="0" bIns="0" rtlCol="0" anchor="ctr"/>
-          <a:lstStyle/>
-          <a:p>
-            <a:pPr algn="ctr" indent="0" marL="0">
-              <a:buNone/>
-            </a:pPr>
-            <a:r>
-              <a:rPr lang="en-US" sz="1800" b="1" dirty="0">
-                <a:solidFill>
-                  <a:schemeClr val="bg1"/>
-                </a:solidFill>
-              </a:rPr>
-              <a:t>Now</a:t>
-            </a:r>
-            <a:endParaRPr lang="en-US" sz="1800" dirty="0"/>
-          </a:p>
-        </p:txBody>
-      </p:sp>
-      <p:sp>
-        <p:nvSpPr>
-          <p:cNvPr id="5" name="Text 3"/>
-          <p:cNvSpPr txBox="1"/>
-          <p:nvPr/>
-        </p:nvSpPr>
-        <p:spPr>
-          <a:xfrm>
-            <a:off x="548640" y="2240280"/>
-            <a:ext cx="2606040" cy="320040"/>
-          </a:xfrm>
-          <a:prstGeom prst="rect">
-            <a:avLst/>
-          </a:prstGeom>
-          <a:noFill/>
-          <a:ln/>
-        </p:spPr>
-        <p:txBody>
-          <a:bodyPr wrap="square" lIns="0" tIns="0" rIns="0" bIns="0" rtlCol="0" anchor="t"/>
-          <a:lstStyle/>
-          <a:p>
-            <a:pPr algn="ctr" indent="0" marL="0">
-              <a:buNone/>
-            </a:pPr>
-            <a:r>
-              <a:rPr lang="en-US" sz="1300" dirty="0">
-                <a:solidFill>
-                  <a:schemeClr val="tx2"/>
-                </a:solidFill>
-              </a:rPr>
-              <a:t>Nov 2026</a:t>
-            </a:r>
-            <a:endParaRPr lang="en-US" sz="1300" dirty="0"/>
-          </a:p>
-        </p:txBody>
-      </p:sp>
-      <p:sp>
-        <p:nvSpPr>
-          <p:cNvPr id="6" name="phase-b-0"/>
-          <p:cNvSpPr/>
-          <p:nvPr/>
-        </p:nvSpPr>
-        <p:spPr>
-          <a:xfrm>
-            <a:off x="548640" y="2651760"/>
-            <a:ext cx="2606040" cy="2834640"/>
-          </a:xfrm>
-          <a:prstGeom prst="roundRect">
-            <a:avLst>
-              <a:gd name="adj" fmla="val 2807"/>
-            </a:avLst>
-          </a:prstGeom>
-          <a:solidFill>
-            <a:schemeClr val="bg2"/>
-          </a:solidFill>
-          <a:ln w="12700">
-            <a:solidFill>
-              <a:schemeClr val="bg2"/>
-            </a:solidFill>
-            <a:prstDash val="solid"/>
-          </a:ln>
-        </p:spPr>
-      </p:sp>
-      <p:sp>
-        <p:nvSpPr>
-          <p:cNvPr id="7" name="Text 5"/>
-          <p:cNvSpPr txBox="1"/>
-          <p:nvPr/>
-        </p:nvSpPr>
-        <p:spPr>
-          <a:xfrm>
-            <a:off x="685800" y="2788920"/>
-            <a:ext cx="2377440" cy="2606040"/>
-          </a:xfrm>
-          <a:prstGeom prst="rect">
-            <a:avLst/>
-          </a:prstGeom>
-          <a:noFill/>
-          <a:ln/>
-        </p:spPr>
-        <p:txBody>
-          <a:bodyPr wrap="square" lIns="0" tIns="0" rIns="0" bIns="0" rtlCol="0" anchor="t"/>
-          <a:lstStyle/>
-          <a:p>
-            <a:pPr marL="342900" indent="-342900">
-              <a:spcAft>
-                <a:spcPts val="800"/>
-              </a:spcAft>
-              <a:buSzPct val="100000"/>
-              <a:buChar char="•"/>
-            </a:pPr>
-            <a:r>
-              <a:rPr lang="en-US" sz="1500" dirty="0">
-                <a:solidFill>
-                  <a:schemeClr val="tx1"/>
-                </a:solidFill>
-              </a:rPr>
-              <a:t>Decisions: sponsor, X1-X5, ServiceNow access, team map</a:t>
-            </a:r>
-            <a:endParaRPr lang="en-US" sz="1500" dirty="0"/>
-          </a:p>
-          <a:p>
-            <a:pPr marL="342900" indent="-342900">
-              <a:spcAft>
-                <a:spcPts val="800"/>
-              </a:spcAft>
-              <a:buSzPct val="100000"/>
-              <a:buChar char="•"/>
-            </a:pPr>
-            <a:r>
-              <a:rPr lang="en-US" sz="1500" dirty="0">
-                <a:solidFill>
-                  <a:schemeClr val="tx1"/>
-                </a:solidFill>
-              </a:rPr>
-              <a:t>Start X1 intake and X2 detection (shadow)</a:t>
-            </a:r>
-            <a:endParaRPr lang="en-US" sz="1500" dirty="0"/>
-          </a:p>
-          <a:p>
-            <a:pPr marL="342900" indent="-342900">
-              <a:spcAft>
-                <a:spcPts val="800"/>
-              </a:spcAft>
-              <a:buSzPct val="100000"/>
-              <a:buChar char="•"/>
-            </a:pPr>
-            <a:r>
-              <a:rPr lang="en-US" sz="1500" dirty="0">
-                <a:solidFill>
-                  <a:schemeClr val="tx1"/>
-                </a:solidFill>
-              </a:rPr>
-              <a:t>QSU: valid, severity-weighted, per team</a:t>
-            </a:r>
-            <a:endParaRPr lang="en-US" sz="1500" dirty="0"/>
-          </a:p>
-          <a:p>
-            <a:pPr marL="342900" indent="-342900">
-              <a:spcAft>
-                <a:spcPts val="800"/>
-              </a:spcAft>
-              <a:buSzPct val="100000"/>
-              <a:buChar char="•"/>
-            </a:pPr>
-            <a:r>
-              <a:rPr lang="en-US" sz="1500" dirty="0">
-                <a:solidFill>
-                  <a:schemeClr val="tx1"/>
-                </a:solidFill>
-              </a:rPr>
-              <a:t>Triage 13 failing routing E2E scenarios</a:t>
-            </a:r>
-            <a:endParaRPr lang="en-US" sz="1500" dirty="0"/>
-          </a:p>
-        </p:txBody>
-      </p:sp>
-      <p:sp>
-        <p:nvSpPr>
-          <p:cNvPr id="8" name="phase-1"/>
-          <p:cNvSpPr/>
-          <p:nvPr/>
-        </p:nvSpPr>
-        <p:spPr>
-          <a:xfrm>
-            <a:off x="3355848" y="1371600"/>
-            <a:ext cx="2697480" cy="777240"/>
-          </a:xfrm>
-          <a:prstGeom prst="chevron">
-            <a:avLst/>
-          </a:prstGeom>
-          <a:solidFill>
-            <a:srgbClr val="1B2A41"/>
-          </a:solidFill>
-          <a:ln w="12700">
-            <a:solidFill>
-              <a:srgbClr val="1B2A41"/>
-            </a:solidFill>
-            <a:prstDash val="solid"/>
-          </a:ln>
-        </p:spPr>
-      </p:sp>
-      <p:sp>
-        <p:nvSpPr>
-          <p:cNvPr id="9" name="Text 7"/>
-          <p:cNvSpPr txBox="1"/>
-          <p:nvPr/>
-        </p:nvSpPr>
-        <p:spPr>
-          <a:xfrm>
-            <a:off x="3630168" y="1371600"/>
-            <a:ext cx="2148840" cy="777240"/>
-          </a:xfrm>
-          <a:prstGeom prst="rect">
-            <a:avLst/>
-          </a:prstGeom>
-          <a:noFill/>
-          <a:ln/>
-        </p:spPr>
-        <p:txBody>
-          <a:bodyPr wrap="square" lIns="0" tIns="0" rIns="0" bIns="0" rtlCol="0" anchor="ctr"/>
-          <a:lstStyle/>
-          <a:p>
-            <a:pPr algn="ctr" indent="0" marL="0">
-              <a:buNone/>
-            </a:pPr>
-            <a:r>
-              <a:rPr lang="en-US" sz="1800" b="1" dirty="0">
-                <a:solidFill>
-                  <a:schemeClr val="bg1"/>
-                </a:solidFill>
-              </a:rPr>
-              <a:t>Q1 2027</a:t>
-            </a:r>
-            <a:endParaRPr lang="en-US" sz="1800" dirty="0"/>
-          </a:p>
-        </p:txBody>
-      </p:sp>
-      <p:sp>
-        <p:nvSpPr>
-          <p:cNvPr id="10" name="Text 8"/>
-          <p:cNvSpPr txBox="1"/>
-          <p:nvPr/>
-        </p:nvSpPr>
-        <p:spPr>
-          <a:xfrm>
-            <a:off x="3355848" y="2240280"/>
-            <a:ext cx="2606040" cy="320040"/>
-          </a:xfrm>
-          <a:prstGeom prst="rect">
-            <a:avLst/>
-          </a:prstGeom>
-          <a:noFill/>
-          <a:ln/>
-        </p:spPr>
-        <p:txBody>
-          <a:bodyPr wrap="square" lIns="0" tIns="0" rIns="0" bIns="0" rtlCol="0" anchor="t"/>
-          <a:lstStyle/>
-          <a:p>
-            <a:pPr algn="ctr" indent="0" marL="0">
-              <a:buNone/>
-            </a:pPr>
-            <a:r>
-              <a:rPr lang="en-US" sz="1300" dirty="0">
-                <a:solidFill>
-                  <a:schemeClr val="tx2"/>
-                </a:solidFill>
-              </a:rPr>
-              <a:t>Jan-Mar</a:t>
-            </a:r>
-            <a:endParaRPr lang="en-US" sz="1300" dirty="0"/>
-          </a:p>
-        </p:txBody>
-      </p:sp>
-      <p:sp>
-        <p:nvSpPr>
-          <p:cNvPr id="11" name="phase-b-1"/>
-          <p:cNvSpPr/>
-          <p:nvPr/>
-        </p:nvSpPr>
-        <p:spPr>
-          <a:xfrm>
-            <a:off x="3355848" y="2651760"/>
-            <a:ext cx="2606040" cy="2834640"/>
-          </a:xfrm>
-          <a:prstGeom prst="roundRect">
-            <a:avLst>
-              <a:gd name="adj" fmla="val 2807"/>
-            </a:avLst>
-          </a:prstGeom>
-          <a:solidFill>
-            <a:schemeClr val="bg2"/>
-          </a:solidFill>
-          <a:ln w="12700">
-            <a:solidFill>
-              <a:schemeClr val="bg2"/>
-            </a:solidFill>
-            <a:prstDash val="solid"/>
-          </a:ln>
-        </p:spPr>
-      </p:sp>
-      <p:sp>
-        <p:nvSpPr>
-          <p:cNvPr id="12" name="Text 10"/>
-          <p:cNvSpPr txBox="1"/>
-          <p:nvPr/>
-        </p:nvSpPr>
-        <p:spPr>
-          <a:xfrm>
-            <a:off x="3493008" y="2788920"/>
-            <a:ext cx="2377440" cy="2606040"/>
-          </a:xfrm>
-          <a:prstGeom prst="rect">
-            <a:avLst/>
-          </a:prstGeom>
-          <a:noFill/>
-          <a:ln/>
-        </p:spPr>
-        <p:txBody>
-          <a:bodyPr wrap="square" lIns="0" tIns="0" rIns="0" bIns="0" rtlCol="0" anchor="t"/>
-          <a:lstStyle/>
-          <a:p>
-            <a:pPr marL="342900" indent="-342900">
-              <a:spcAft>
-                <a:spcPts val="800"/>
-              </a:spcAft>
-              <a:buSzPct val="100000"/>
-              <a:buChar char="•"/>
-            </a:pPr>
-            <a:r>
-              <a:rPr lang="en-US" sz="1500" dirty="0">
-                <a:solidFill>
-                  <a:schemeClr val="tx1"/>
-                </a:solidFill>
-              </a:rPr>
-              <a:t>X3/X4 step 1 (hotspot and bug-fix PRs)</a:t>
-            </a:r>
-            <a:endParaRPr lang="en-US" sz="1500" dirty="0"/>
-          </a:p>
-          <a:p>
-            <a:pPr marL="342900" indent="-342900">
-              <a:spcAft>
-                <a:spcPts val="800"/>
-              </a:spcAft>
-              <a:buSzPct val="100000"/>
-              <a:buChar char="•"/>
-            </a:pPr>
-            <a:r>
-              <a:rPr lang="en-US" sz="1500" dirty="0">
-                <a:solidFill>
-                  <a:schemeClr val="tx1"/>
-                </a:solidFill>
-              </a:rPr>
-              <a:t>X5 with product owners</a:t>
-            </a:r>
-            <a:endParaRPr lang="en-US" sz="1500" dirty="0"/>
-          </a:p>
-          <a:p>
-            <a:pPr marL="342900" indent="-342900">
-              <a:spcAft>
-                <a:spcPts val="800"/>
-              </a:spcAft>
-              <a:buSzPct val="100000"/>
-              <a:buChar char="•"/>
-            </a:pPr>
-            <a:r>
-              <a:rPr lang="en-US" sz="1500" dirty="0">
-                <a:solidFill>
-                  <a:schemeClr val="tx1"/>
-                </a:solidFill>
-              </a:rPr>
-              <a:t>Monthly quality review per team</a:t>
-            </a:r>
-            <a:endParaRPr lang="en-US" sz="1500" dirty="0"/>
-          </a:p>
-          <a:p>
-            <a:pPr marL="342900" indent="-342900">
-              <a:spcAft>
-                <a:spcPts val="800"/>
-              </a:spcAft>
-              <a:buSzPct val="100000"/>
-              <a:buChar char="•"/>
-            </a:pPr>
-            <a:r>
-              <a:rPr lang="en-US" sz="1500" dirty="0">
-                <a:solidFill>
-                  <a:schemeClr val="tx1"/>
-                </a:solidFill>
-              </a:rPr>
-              <a:t>Re-test the AI effect (90 days)</a:t>
-            </a:r>
-            <a:endParaRPr lang="en-US" sz="1500" dirty="0"/>
-          </a:p>
-        </p:txBody>
-      </p:sp>
-      <p:sp>
-        <p:nvSpPr>
-          <p:cNvPr id="13" name="phase-2"/>
-          <p:cNvSpPr/>
-          <p:nvPr/>
-        </p:nvSpPr>
-        <p:spPr>
-          <a:xfrm>
-            <a:off x="6163056" y="1371600"/>
-            <a:ext cx="2697480" cy="777240"/>
-          </a:xfrm>
-          <a:prstGeom prst="chevron">
-            <a:avLst/>
-          </a:prstGeom>
-          <a:solidFill>
-            <a:srgbClr val="1B2A41"/>
-          </a:solidFill>
-          <a:ln w="12700">
-            <a:solidFill>
-              <a:srgbClr val="1B2A41"/>
-            </a:solidFill>
-            <a:prstDash val="solid"/>
-          </a:ln>
-        </p:spPr>
-      </p:sp>
-      <p:sp>
-        <p:nvSpPr>
-          <p:cNvPr id="14" name="Text 12"/>
-          <p:cNvSpPr txBox="1"/>
-          <p:nvPr/>
-        </p:nvSpPr>
-        <p:spPr>
-          <a:xfrm>
-            <a:off x="6437376" y="1371600"/>
-            <a:ext cx="2148840" cy="777240"/>
-          </a:xfrm>
-          <a:prstGeom prst="rect">
-            <a:avLst/>
-          </a:prstGeom>
-          <a:noFill/>
-          <a:ln/>
-        </p:spPr>
-        <p:txBody>
-          <a:bodyPr wrap="square" lIns="0" tIns="0" rIns="0" bIns="0" rtlCol="0" anchor="ctr"/>
-          <a:lstStyle/>
-          <a:p>
-            <a:pPr algn="ctr" indent="0" marL="0">
-              <a:buNone/>
-            </a:pPr>
-            <a:r>
-              <a:rPr lang="en-US" sz="1800" b="1" dirty="0">
-                <a:solidFill>
-                  <a:schemeClr val="bg1"/>
-                </a:solidFill>
-              </a:rPr>
-              <a:t>Q2 2027</a:t>
-            </a:r>
-            <a:endParaRPr lang="en-US" sz="1800" dirty="0"/>
-          </a:p>
-        </p:txBody>
-      </p:sp>
-      <p:sp>
-        <p:nvSpPr>
-          <p:cNvPr id="15" name="Text 13"/>
-          <p:cNvSpPr txBox="1"/>
-          <p:nvPr/>
-        </p:nvSpPr>
-        <p:spPr>
-          <a:xfrm>
-            <a:off x="6163056" y="2240280"/>
-            <a:ext cx="2606040" cy="320040"/>
-          </a:xfrm>
-          <a:prstGeom prst="rect">
-            <a:avLst/>
-          </a:prstGeom>
-          <a:noFill/>
-          <a:ln/>
-        </p:spPr>
-        <p:txBody>
-          <a:bodyPr wrap="square" lIns="0" tIns="0" rIns="0" bIns="0" rtlCol="0" anchor="t"/>
-          <a:lstStyle/>
-          <a:p>
-            <a:pPr algn="ctr" indent="0" marL="0">
-              <a:buNone/>
-            </a:pPr>
-            <a:r>
-              <a:rPr lang="en-US" sz="1300" dirty="0">
-                <a:solidFill>
-                  <a:schemeClr val="tx2"/>
-                </a:solidFill>
-              </a:rPr>
-              <a:t>April review</a:t>
-            </a:r>
-            <a:endParaRPr lang="en-US" sz="1300" dirty="0"/>
-          </a:p>
-        </p:txBody>
-      </p:sp>
-      <p:sp>
-        <p:nvSpPr>
-          <p:cNvPr id="16" name="phase-b-2"/>
-          <p:cNvSpPr/>
-          <p:nvPr/>
-        </p:nvSpPr>
-        <p:spPr>
-          <a:xfrm>
-            <a:off x="6163056" y="2651760"/>
-            <a:ext cx="2606040" cy="2834640"/>
-          </a:xfrm>
-          <a:prstGeom prst="roundRect">
-            <a:avLst>
-              <a:gd name="adj" fmla="val 2807"/>
-            </a:avLst>
-          </a:prstGeom>
-          <a:solidFill>
-            <a:schemeClr val="bg2"/>
-          </a:solidFill>
-          <a:ln w="12700">
-            <a:solidFill>
-              <a:schemeClr val="bg2"/>
-            </a:solidFill>
-            <a:prstDash val="solid"/>
-          </a:ln>
-        </p:spPr>
-      </p:sp>
-      <p:sp>
-        <p:nvSpPr>
-          <p:cNvPr id="17" name="Text 15"/>
-          <p:cNvSpPr txBox="1"/>
-          <p:nvPr/>
-        </p:nvSpPr>
-        <p:spPr>
-          <a:xfrm>
-            <a:off x="6300216" y="2788920"/>
-            <a:ext cx="2377440" cy="2606040"/>
-          </a:xfrm>
-          <a:prstGeom prst="rect">
-            <a:avLst/>
-          </a:prstGeom>
-          <a:noFill/>
-          <a:ln/>
-        </p:spPr>
-        <p:txBody>
-          <a:bodyPr wrap="square" lIns="0" tIns="0" rIns="0" bIns="0" rtlCol="0" anchor="t"/>
-          <a:lstStyle/>
-          <a:p>
-            <a:pPr marL="342900" indent="-342900">
-              <a:spcAft>
-                <a:spcPts val="800"/>
-              </a:spcAft>
-              <a:buSzPct val="100000"/>
-              <a:buChar char="•"/>
-            </a:pPr>
-            <a:r>
-              <a:rPr lang="en-US" sz="1500" dirty="0">
-                <a:solidFill>
-                  <a:schemeClr val="tx1"/>
-                </a:solidFill>
-              </a:rPr>
-              <a:t>X3/X4 step 2</a:t>
-            </a:r>
-            <a:endParaRPr lang="en-US" sz="1500" dirty="0"/>
-          </a:p>
-          <a:p>
-            <a:pPr marL="342900" indent="-342900">
-              <a:spcAft>
-                <a:spcPts val="800"/>
-              </a:spcAft>
-              <a:buSzPct val="100000"/>
-              <a:buChar char="•"/>
-            </a:pPr>
-            <a:r>
-              <a:rPr lang="en-US" sz="1500" dirty="0">
-                <a:solidFill>
-                  <a:schemeClr val="tx1"/>
-                </a:solidFill>
-              </a:rPr>
-              <a:t>Results vs controls</a:t>
-            </a:r>
-            <a:endParaRPr lang="en-US" sz="1500" dirty="0"/>
-          </a:p>
-          <a:p>
-            <a:pPr marL="342900" indent="-342900">
-              <a:spcAft>
-                <a:spcPts val="800"/>
-              </a:spcAft>
-              <a:buSzPct val="100000"/>
-              <a:buChar char="•"/>
-            </a:pPr>
-            <a:r>
-              <a:rPr lang="en-US" sz="1500" dirty="0">
-                <a:solidFill>
-                  <a:schemeClr val="tx1"/>
-                </a:solidFill>
-              </a:rPr>
-              <a:t>Model v1 with justified targets</a:t>
-            </a:r>
-            <a:endParaRPr lang="en-US" sz="1500" dirty="0"/>
-          </a:p>
-          <a:p>
-            <a:pPr marL="342900" indent="-342900">
-              <a:spcAft>
-                <a:spcPts val="800"/>
-              </a:spcAft>
-              <a:buSzPct val="100000"/>
-              <a:buChar char="•"/>
-            </a:pPr>
-            <a:r>
-              <a:rPr lang="en-US" sz="1500" dirty="0">
-                <a:solidFill>
-                  <a:schemeClr val="tx1"/>
-                </a:solidFill>
-              </a:rPr>
-              <a:t>Decide which checks block</a:t>
-            </a:r>
-            <a:endParaRPr lang="en-US" sz="1500" dirty="0"/>
-          </a:p>
-        </p:txBody>
-      </p:sp>
-      <p:sp>
-        <p:nvSpPr>
-          <p:cNvPr id="18" name="phase-3"/>
-          <p:cNvSpPr/>
-          <p:nvPr/>
-        </p:nvSpPr>
-        <p:spPr>
-          <a:xfrm>
-            <a:off x="8970264" y="1371600"/>
-            <a:ext cx="2697480" cy="777240"/>
-          </a:xfrm>
-          <a:prstGeom prst="chevron">
-            <a:avLst/>
-          </a:prstGeom>
-          <a:solidFill>
-            <a:srgbClr val="1B2A41"/>
-          </a:solidFill>
-          <a:ln w="12700">
-            <a:solidFill>
-              <a:srgbClr val="1B2A41"/>
-            </a:solidFill>
-            <a:prstDash val="solid"/>
-          </a:ln>
-        </p:spPr>
-      </p:sp>
-      <p:sp>
-        <p:nvSpPr>
-          <p:cNvPr id="19" name="Text 17"/>
-          <p:cNvSpPr txBox="1"/>
-          <p:nvPr/>
-        </p:nvSpPr>
-        <p:spPr>
-          <a:xfrm>
-            <a:off x="9244584" y="1371600"/>
-            <a:ext cx="2148840" cy="777240"/>
-          </a:xfrm>
-          <a:prstGeom prst="rect">
-            <a:avLst/>
-          </a:prstGeom>
-          <a:noFill/>
-          <a:ln/>
-        </p:spPr>
-        <p:txBody>
-          <a:bodyPr wrap="square" lIns="0" tIns="0" rIns="0" bIns="0" rtlCol="0" anchor="ctr"/>
-          <a:lstStyle/>
-          <a:p>
-            <a:pPr algn="ctr" indent="0" marL="0">
-              <a:buNone/>
-            </a:pPr>
-            <a:r>
-              <a:rPr lang="en-US" sz="1800" b="1" dirty="0">
-                <a:solidFill>
-                  <a:schemeClr val="bg1"/>
-                </a:solidFill>
-              </a:rPr>
-              <a:t>H2 2027</a:t>
-            </a:r>
-            <a:endParaRPr lang="en-US" sz="1800" dirty="0"/>
-          </a:p>
-        </p:txBody>
-      </p:sp>
-      <p:sp>
-        <p:nvSpPr>
-          <p:cNvPr id="20" name="Text 18"/>
-          <p:cNvSpPr txBox="1"/>
-          <p:nvPr/>
-        </p:nvSpPr>
-        <p:spPr>
-          <a:xfrm>
-            <a:off x="8970264" y="2240280"/>
-            <a:ext cx="2606040" cy="320040"/>
-          </a:xfrm>
-          <a:prstGeom prst="rect">
-            <a:avLst/>
-          </a:prstGeom>
-          <a:noFill/>
-          <a:ln/>
-        </p:spPr>
-        <p:txBody>
-          <a:bodyPr wrap="square" lIns="0" tIns="0" rIns="0" bIns="0" rtlCol="0" anchor="t"/>
-          <a:lstStyle/>
-          <a:p>
-            <a:pPr algn="ctr" indent="0" marL="0">
-              <a:buNone/>
-            </a:pPr>
-            <a:r>
-              <a:rPr lang="en-US" sz="1300" dirty="0">
-                <a:solidFill>
-                  <a:schemeClr val="tx2"/>
-                </a:solidFill>
-              </a:rPr>
-              <a:t>Jul-Dec</a:t>
-            </a:r>
-            <a:endParaRPr lang="en-US" sz="1300" dirty="0"/>
-          </a:p>
-        </p:txBody>
-      </p:sp>
-      <p:sp>
-        <p:nvSpPr>
-          <p:cNvPr id="21" name="phase-b-3"/>
-          <p:cNvSpPr/>
-          <p:nvPr/>
-        </p:nvSpPr>
-        <p:spPr>
-          <a:xfrm>
-            <a:off x="8970264" y="2651760"/>
-            <a:ext cx="2606040" cy="2834640"/>
-          </a:xfrm>
-          <a:prstGeom prst="roundRect">
-            <a:avLst>
-              <a:gd name="adj" fmla="val 2807"/>
-            </a:avLst>
-          </a:prstGeom>
-          <a:solidFill>
-            <a:schemeClr val="bg2"/>
-          </a:solidFill>
-          <a:ln w="12700">
-            <a:solidFill>
-              <a:schemeClr val="bg2"/>
-            </a:solidFill>
-            <a:prstDash val="solid"/>
-          </a:ln>
-        </p:spPr>
-      </p:sp>
-      <p:sp>
-        <p:nvSpPr>
-          <p:cNvPr id="22" name="Text 20"/>
-          <p:cNvSpPr txBox="1"/>
-          <p:nvPr/>
-        </p:nvSpPr>
-        <p:spPr>
-          <a:xfrm>
-            <a:off x="9107424" y="2788920"/>
-            <a:ext cx="2377440" cy="2606040"/>
-          </a:xfrm>
-          <a:prstGeom prst="rect">
-            <a:avLst/>
-          </a:prstGeom>
-          <a:noFill/>
-          <a:ln/>
-        </p:spPr>
-        <p:txBody>
-          <a:bodyPr wrap="square" lIns="0" tIns="0" rIns="0" bIns="0" rtlCol="0" anchor="t"/>
-          <a:lstStyle/>
-          <a:p>
-            <a:pPr marL="342900" indent="-342900">
-              <a:spcAft>
-                <a:spcPts val="800"/>
-              </a:spcAft>
-              <a:buSzPct val="100000"/>
-              <a:buChar char="•"/>
-            </a:pPr>
-            <a:r>
-              <a:rPr lang="en-US" sz="1500" dirty="0">
-                <a:solidFill>
-                  <a:schemeClr val="tx1"/>
-                </a:solidFill>
-              </a:rPr>
-              <a:t>Spread proven practices to all domains</a:t>
-            </a:r>
-            <a:endParaRPr lang="en-US" sz="1500" dirty="0"/>
-          </a:p>
-          <a:p>
-            <a:pPr marL="342900" indent="-342900">
-              <a:spcAft>
-                <a:spcPts val="800"/>
-              </a:spcAft>
-              <a:buSzPct val="100000"/>
-              <a:buChar char="•"/>
-            </a:pPr>
-            <a:r>
-              <a:rPr lang="en-US" sz="1500" dirty="0">
-                <a:solidFill>
-                  <a:schemeClr val="tx1"/>
-                </a:solidFill>
-              </a:rPr>
-              <a:t>Decide RIA agents, mutation, harness from evidence</a:t>
-            </a:r>
-            <a:endParaRPr lang="en-US" sz="1500" dirty="0"/>
-          </a:p>
-        </p:txBody>
-      </p:sp>
-      <p:sp>
-        <p:nvSpPr>
-          <p:cNvPr id="25" name="Slide Number Placeholder 0"/>
-          <p:cNvSpPr>
-            <a:spLocks noGrp="1"/>
-          </p:cNvSpPr>
-          <p:nvPr>
-            <p:ph type="sldNum" sz="quarter" idx="4294967295"/>
-          </p:nvPr>
-        </p:nvSpPr>
-        <p:spPr>
-          <a:xfrm>
-            <a:off x="11247120" y="6400800"/>
-            <a:ext cx="457200" cy="274320"/>
-          </a:xfrm>
-          <a:prstGeom prst="rect">
-            <a:avLst/>
-          </a:prstGeom>
-          <a:extLst>
-            <a:ext uri="{C572A759-6A51-4108-AA02-DFA0A04FC94B}">
-              <ma14:wrappingTextBoxFlag xmlns:ma14="http://schemas.microsoft.com/office/mac/drawingml/2011/main" val="0"/>
-            </a:ext>
-          </a:extLst>
-        </p:spPr>
-        <p:txBody>
-          <a:bodyPr/>
-          <a:lstStyle>
-            <a:lvl1pPr>
-              <a:defRPr sz="1000">
-                <a:solidFill>
-                  <a:schemeClr val="tx2"/>
-                </a:solidFill>
-              </a:defRPr>
-            </a:lvl1pPr>
-          </a:lstStyle>
-          <a:p>
-            <a:pPr algn="r"/>
-            <a:fld id="{F7021451-1387-4CA6-816F-3879F97B5CBC}" type="slidenum">
-              <a:rPr b="0" lang="en-US"/>
               <a:t>13</a:t>
             </a:fld>
             <a:endParaRPr lang="en-US"/>
@@ -9661,6 +10575,950 @@
             <a:r>
               <a:rPr lang="en-US" sz="3000" b="1" dirty="0">
                 <a:solidFill>
+                  <a:schemeClr val="tx1"/>
+                </a:solidFill>
+              </a:rPr>
+              <a:t>When: measure first, test in a few teams, then spread</a:t>
+            </a:r>
+            <a:endParaRPr lang="en-US" sz="3000" dirty="0"/>
+          </a:p>
+        </p:txBody>
+      </p:sp>
+      <p:sp>
+        <p:nvSpPr>
+          <p:cNvPr id="3" name="phase-0"/>
+          <p:cNvSpPr/>
+          <p:nvPr/>
+        </p:nvSpPr>
+        <p:spPr>
+          <a:xfrm>
+            <a:off x="548640" y="1371600"/>
+            <a:ext cx="2697480" cy="777240"/>
+          </a:xfrm>
+          <a:prstGeom prst="chevron">
+            <a:avLst/>
+          </a:prstGeom>
+          <a:solidFill>
+            <a:srgbClr val="C8443D"/>
+          </a:solidFill>
+          <a:ln w="12700">
+            <a:solidFill>
+              <a:srgbClr val="C8443D"/>
+            </a:solidFill>
+            <a:prstDash val="solid"/>
+          </a:ln>
+        </p:spPr>
+      </p:sp>
+      <p:sp>
+        <p:nvSpPr>
+          <p:cNvPr id="4" name="Text 2"/>
+          <p:cNvSpPr txBox="1"/>
+          <p:nvPr/>
+        </p:nvSpPr>
+        <p:spPr>
+          <a:xfrm>
+            <a:off x="822960" y="1371600"/>
+            <a:ext cx="2148840" cy="777240"/>
+          </a:xfrm>
+          <a:prstGeom prst="rect">
+            <a:avLst/>
+          </a:prstGeom>
+          <a:noFill/>
+          <a:ln/>
+        </p:spPr>
+        <p:txBody>
+          <a:bodyPr wrap="square" lIns="0" tIns="0" rIns="0" bIns="0" rtlCol="0" anchor="ctr"/>
+          <a:lstStyle/>
+          <a:p>
+            <a:pPr algn="ctr" indent="0" marL="0">
+              <a:buNone/>
+            </a:pPr>
+            <a:r>
+              <a:rPr lang="en-US" sz="1800" b="1" dirty="0">
+                <a:solidFill>
+                  <a:schemeClr val="bg1"/>
+                </a:solidFill>
+              </a:rPr>
+              <a:t>Now</a:t>
+            </a:r>
+            <a:endParaRPr lang="en-US" sz="1800" dirty="0"/>
+          </a:p>
+        </p:txBody>
+      </p:sp>
+      <p:sp>
+        <p:nvSpPr>
+          <p:cNvPr id="5" name="Text 3"/>
+          <p:cNvSpPr txBox="1"/>
+          <p:nvPr/>
+        </p:nvSpPr>
+        <p:spPr>
+          <a:xfrm>
+            <a:off x="548640" y="2240280"/>
+            <a:ext cx="2606040" cy="320040"/>
+          </a:xfrm>
+          <a:prstGeom prst="rect">
+            <a:avLst/>
+          </a:prstGeom>
+          <a:noFill/>
+          <a:ln/>
+        </p:spPr>
+        <p:txBody>
+          <a:bodyPr wrap="square" lIns="0" tIns="0" rIns="0" bIns="0" rtlCol="0" anchor="t"/>
+          <a:lstStyle/>
+          <a:p>
+            <a:pPr algn="ctr" indent="0" marL="0">
+              <a:buNone/>
+            </a:pPr>
+            <a:r>
+              <a:rPr lang="en-US" sz="1300" dirty="0">
+                <a:solidFill>
+                  <a:schemeClr val="tx2"/>
+                </a:solidFill>
+              </a:rPr>
+              <a:t>Nov 2026</a:t>
+            </a:r>
+            <a:endParaRPr lang="en-US" sz="1300" dirty="0"/>
+          </a:p>
+        </p:txBody>
+      </p:sp>
+      <p:sp>
+        <p:nvSpPr>
+          <p:cNvPr id="6" name="phase-b-0"/>
+          <p:cNvSpPr/>
+          <p:nvPr/>
+        </p:nvSpPr>
+        <p:spPr>
+          <a:xfrm>
+            <a:off x="548640" y="2651760"/>
+            <a:ext cx="2606040" cy="2834640"/>
+          </a:xfrm>
+          <a:prstGeom prst="roundRect">
+            <a:avLst>
+              <a:gd name="adj" fmla="val 2807"/>
+            </a:avLst>
+          </a:prstGeom>
+          <a:solidFill>
+            <a:schemeClr val="bg2"/>
+          </a:solidFill>
+          <a:ln w="12700">
+            <a:solidFill>
+              <a:schemeClr val="bg2"/>
+            </a:solidFill>
+            <a:prstDash val="solid"/>
+          </a:ln>
+        </p:spPr>
+      </p:sp>
+      <p:sp>
+        <p:nvSpPr>
+          <p:cNvPr id="7" name="Text 5"/>
+          <p:cNvSpPr txBox="1"/>
+          <p:nvPr/>
+        </p:nvSpPr>
+        <p:spPr>
+          <a:xfrm>
+            <a:off x="685800" y="2788920"/>
+            <a:ext cx="2377440" cy="2606040"/>
+          </a:xfrm>
+          <a:prstGeom prst="rect">
+            <a:avLst/>
+          </a:prstGeom>
+          <a:noFill/>
+          <a:ln/>
+        </p:spPr>
+        <p:txBody>
+          <a:bodyPr wrap="square" lIns="0" tIns="0" rIns="0" bIns="0" rtlCol="0" anchor="t"/>
+          <a:lstStyle/>
+          <a:p>
+            <a:pPr marL="342900" indent="-342900">
+              <a:spcAft>
+                <a:spcPts val="800"/>
+              </a:spcAft>
+              <a:buSzPct val="100000"/>
+              <a:buChar char="•"/>
+            </a:pPr>
+            <a:r>
+              <a:rPr lang="en-US" sz="1500" dirty="0">
+                <a:solidFill>
+                  <a:schemeClr val="tx1"/>
+                </a:solidFill>
+              </a:rPr>
+              <a:t>Decisions: sponsor, X1-X5, ServiceNow access, team map</a:t>
+            </a:r>
+            <a:endParaRPr lang="en-US" sz="1500" dirty="0"/>
+          </a:p>
+          <a:p>
+            <a:pPr marL="342900" indent="-342900">
+              <a:spcAft>
+                <a:spcPts val="800"/>
+              </a:spcAft>
+              <a:buSzPct val="100000"/>
+              <a:buChar char="•"/>
+            </a:pPr>
+            <a:r>
+              <a:rPr lang="en-US" sz="1500" dirty="0">
+                <a:solidFill>
+                  <a:schemeClr val="tx1"/>
+                </a:solidFill>
+              </a:rPr>
+              <a:t>Start X1 intake and X2 detection (shadow)</a:t>
+            </a:r>
+            <a:endParaRPr lang="en-US" sz="1500" dirty="0"/>
+          </a:p>
+          <a:p>
+            <a:pPr marL="342900" indent="-342900">
+              <a:spcAft>
+                <a:spcPts val="800"/>
+              </a:spcAft>
+              <a:buSzPct val="100000"/>
+              <a:buChar char="•"/>
+            </a:pPr>
+            <a:r>
+              <a:rPr lang="en-US" sz="1500" dirty="0">
+                <a:solidFill>
+                  <a:schemeClr val="tx1"/>
+                </a:solidFill>
+              </a:rPr>
+              <a:t>QSU: valid, severity-weighted, per team</a:t>
+            </a:r>
+            <a:endParaRPr lang="en-US" sz="1500" dirty="0"/>
+          </a:p>
+          <a:p>
+            <a:pPr marL="342900" indent="-342900">
+              <a:spcAft>
+                <a:spcPts val="800"/>
+              </a:spcAft>
+              <a:buSzPct val="100000"/>
+              <a:buChar char="•"/>
+            </a:pPr>
+            <a:r>
+              <a:rPr lang="en-US" sz="1500" dirty="0">
+                <a:solidFill>
+                  <a:schemeClr val="tx1"/>
+                </a:solidFill>
+              </a:rPr>
+              <a:t>Triage 13 failing routing E2E scenarios</a:t>
+            </a:r>
+            <a:endParaRPr lang="en-US" sz="1500" dirty="0"/>
+          </a:p>
+        </p:txBody>
+      </p:sp>
+      <p:sp>
+        <p:nvSpPr>
+          <p:cNvPr id="8" name="phase-1"/>
+          <p:cNvSpPr/>
+          <p:nvPr/>
+        </p:nvSpPr>
+        <p:spPr>
+          <a:xfrm>
+            <a:off x="3355848" y="1371600"/>
+            <a:ext cx="2697480" cy="777240"/>
+          </a:xfrm>
+          <a:prstGeom prst="chevron">
+            <a:avLst/>
+          </a:prstGeom>
+          <a:solidFill>
+            <a:srgbClr val="1B2A41"/>
+          </a:solidFill>
+          <a:ln w="12700">
+            <a:solidFill>
+              <a:srgbClr val="1B2A41"/>
+            </a:solidFill>
+            <a:prstDash val="solid"/>
+          </a:ln>
+        </p:spPr>
+      </p:sp>
+      <p:sp>
+        <p:nvSpPr>
+          <p:cNvPr id="9" name="Text 7"/>
+          <p:cNvSpPr txBox="1"/>
+          <p:nvPr/>
+        </p:nvSpPr>
+        <p:spPr>
+          <a:xfrm>
+            <a:off x="3630168" y="1371600"/>
+            <a:ext cx="2148840" cy="777240"/>
+          </a:xfrm>
+          <a:prstGeom prst="rect">
+            <a:avLst/>
+          </a:prstGeom>
+          <a:noFill/>
+          <a:ln/>
+        </p:spPr>
+        <p:txBody>
+          <a:bodyPr wrap="square" lIns="0" tIns="0" rIns="0" bIns="0" rtlCol="0" anchor="ctr"/>
+          <a:lstStyle/>
+          <a:p>
+            <a:pPr algn="ctr" indent="0" marL="0">
+              <a:buNone/>
+            </a:pPr>
+            <a:r>
+              <a:rPr lang="en-US" sz="1800" b="1" dirty="0">
+                <a:solidFill>
+                  <a:schemeClr val="bg1"/>
+                </a:solidFill>
+              </a:rPr>
+              <a:t>Q1 2027</a:t>
+            </a:r>
+            <a:endParaRPr lang="en-US" sz="1800" dirty="0"/>
+          </a:p>
+        </p:txBody>
+      </p:sp>
+      <p:sp>
+        <p:nvSpPr>
+          <p:cNvPr id="10" name="Text 8"/>
+          <p:cNvSpPr txBox="1"/>
+          <p:nvPr/>
+        </p:nvSpPr>
+        <p:spPr>
+          <a:xfrm>
+            <a:off x="3355848" y="2240280"/>
+            <a:ext cx="2606040" cy="320040"/>
+          </a:xfrm>
+          <a:prstGeom prst="rect">
+            <a:avLst/>
+          </a:prstGeom>
+          <a:noFill/>
+          <a:ln/>
+        </p:spPr>
+        <p:txBody>
+          <a:bodyPr wrap="square" lIns="0" tIns="0" rIns="0" bIns="0" rtlCol="0" anchor="t"/>
+          <a:lstStyle/>
+          <a:p>
+            <a:pPr algn="ctr" indent="0" marL="0">
+              <a:buNone/>
+            </a:pPr>
+            <a:r>
+              <a:rPr lang="en-US" sz="1300" dirty="0">
+                <a:solidFill>
+                  <a:schemeClr val="tx2"/>
+                </a:solidFill>
+              </a:rPr>
+              <a:t>Jan-Mar</a:t>
+            </a:r>
+            <a:endParaRPr lang="en-US" sz="1300" dirty="0"/>
+          </a:p>
+        </p:txBody>
+      </p:sp>
+      <p:sp>
+        <p:nvSpPr>
+          <p:cNvPr id="11" name="phase-b-1"/>
+          <p:cNvSpPr/>
+          <p:nvPr/>
+        </p:nvSpPr>
+        <p:spPr>
+          <a:xfrm>
+            <a:off x="3355848" y="2651760"/>
+            <a:ext cx="2606040" cy="2834640"/>
+          </a:xfrm>
+          <a:prstGeom prst="roundRect">
+            <a:avLst>
+              <a:gd name="adj" fmla="val 2807"/>
+            </a:avLst>
+          </a:prstGeom>
+          <a:solidFill>
+            <a:schemeClr val="bg2"/>
+          </a:solidFill>
+          <a:ln w="12700">
+            <a:solidFill>
+              <a:schemeClr val="bg2"/>
+            </a:solidFill>
+            <a:prstDash val="solid"/>
+          </a:ln>
+        </p:spPr>
+      </p:sp>
+      <p:sp>
+        <p:nvSpPr>
+          <p:cNvPr id="12" name="Text 10"/>
+          <p:cNvSpPr txBox="1"/>
+          <p:nvPr/>
+        </p:nvSpPr>
+        <p:spPr>
+          <a:xfrm>
+            <a:off x="3493008" y="2788920"/>
+            <a:ext cx="2377440" cy="2606040"/>
+          </a:xfrm>
+          <a:prstGeom prst="rect">
+            <a:avLst/>
+          </a:prstGeom>
+          <a:noFill/>
+          <a:ln/>
+        </p:spPr>
+        <p:txBody>
+          <a:bodyPr wrap="square" lIns="0" tIns="0" rIns="0" bIns="0" rtlCol="0" anchor="t"/>
+          <a:lstStyle/>
+          <a:p>
+            <a:pPr marL="342900" indent="-342900">
+              <a:spcAft>
+                <a:spcPts val="800"/>
+              </a:spcAft>
+              <a:buSzPct val="100000"/>
+              <a:buChar char="•"/>
+            </a:pPr>
+            <a:r>
+              <a:rPr lang="en-US" sz="1500" dirty="0">
+                <a:solidFill>
+                  <a:schemeClr val="tx1"/>
+                </a:solidFill>
+              </a:rPr>
+              <a:t>X3/X4 step 1 (hotspot and bug-fix PRs)</a:t>
+            </a:r>
+            <a:endParaRPr lang="en-US" sz="1500" dirty="0"/>
+          </a:p>
+          <a:p>
+            <a:pPr marL="342900" indent="-342900">
+              <a:spcAft>
+                <a:spcPts val="800"/>
+              </a:spcAft>
+              <a:buSzPct val="100000"/>
+              <a:buChar char="•"/>
+            </a:pPr>
+            <a:r>
+              <a:rPr lang="en-US" sz="1500" dirty="0">
+                <a:solidFill>
+                  <a:schemeClr val="tx1"/>
+                </a:solidFill>
+              </a:rPr>
+              <a:t>X5 with product owners</a:t>
+            </a:r>
+            <a:endParaRPr lang="en-US" sz="1500" dirty="0"/>
+          </a:p>
+          <a:p>
+            <a:pPr marL="342900" indent="-342900">
+              <a:spcAft>
+                <a:spcPts val="800"/>
+              </a:spcAft>
+              <a:buSzPct val="100000"/>
+              <a:buChar char="•"/>
+            </a:pPr>
+            <a:r>
+              <a:rPr lang="en-US" sz="1500" dirty="0">
+                <a:solidFill>
+                  <a:schemeClr val="tx1"/>
+                </a:solidFill>
+              </a:rPr>
+              <a:t>Monthly quality review per team</a:t>
+            </a:r>
+            <a:endParaRPr lang="en-US" sz="1500" dirty="0"/>
+          </a:p>
+          <a:p>
+            <a:pPr marL="342900" indent="-342900">
+              <a:spcAft>
+                <a:spcPts val="800"/>
+              </a:spcAft>
+              <a:buSzPct val="100000"/>
+              <a:buChar char="•"/>
+            </a:pPr>
+            <a:r>
+              <a:rPr lang="en-US" sz="1500" dirty="0">
+                <a:solidFill>
+                  <a:schemeClr val="tx1"/>
+                </a:solidFill>
+              </a:rPr>
+              <a:t>Re-test the AI effect (90 days)</a:t>
+            </a:r>
+            <a:endParaRPr lang="en-US" sz="1500" dirty="0"/>
+          </a:p>
+        </p:txBody>
+      </p:sp>
+      <p:sp>
+        <p:nvSpPr>
+          <p:cNvPr id="13" name="phase-2"/>
+          <p:cNvSpPr/>
+          <p:nvPr/>
+        </p:nvSpPr>
+        <p:spPr>
+          <a:xfrm>
+            <a:off x="6163056" y="1371600"/>
+            <a:ext cx="2697480" cy="777240"/>
+          </a:xfrm>
+          <a:prstGeom prst="chevron">
+            <a:avLst/>
+          </a:prstGeom>
+          <a:solidFill>
+            <a:srgbClr val="1B2A41"/>
+          </a:solidFill>
+          <a:ln w="12700">
+            <a:solidFill>
+              <a:srgbClr val="1B2A41"/>
+            </a:solidFill>
+            <a:prstDash val="solid"/>
+          </a:ln>
+        </p:spPr>
+      </p:sp>
+      <p:sp>
+        <p:nvSpPr>
+          <p:cNvPr id="14" name="Text 12"/>
+          <p:cNvSpPr txBox="1"/>
+          <p:nvPr/>
+        </p:nvSpPr>
+        <p:spPr>
+          <a:xfrm>
+            <a:off x="6437376" y="1371600"/>
+            <a:ext cx="2148840" cy="777240"/>
+          </a:xfrm>
+          <a:prstGeom prst="rect">
+            <a:avLst/>
+          </a:prstGeom>
+          <a:noFill/>
+          <a:ln/>
+        </p:spPr>
+        <p:txBody>
+          <a:bodyPr wrap="square" lIns="0" tIns="0" rIns="0" bIns="0" rtlCol="0" anchor="ctr"/>
+          <a:lstStyle/>
+          <a:p>
+            <a:pPr algn="ctr" indent="0" marL="0">
+              <a:buNone/>
+            </a:pPr>
+            <a:r>
+              <a:rPr lang="en-US" sz="1800" b="1" dirty="0">
+                <a:solidFill>
+                  <a:schemeClr val="bg1"/>
+                </a:solidFill>
+              </a:rPr>
+              <a:t>Q2 2027</a:t>
+            </a:r>
+            <a:endParaRPr lang="en-US" sz="1800" dirty="0"/>
+          </a:p>
+        </p:txBody>
+      </p:sp>
+      <p:sp>
+        <p:nvSpPr>
+          <p:cNvPr id="15" name="Text 13"/>
+          <p:cNvSpPr txBox="1"/>
+          <p:nvPr/>
+        </p:nvSpPr>
+        <p:spPr>
+          <a:xfrm>
+            <a:off x="6163056" y="2240280"/>
+            <a:ext cx="2606040" cy="320040"/>
+          </a:xfrm>
+          <a:prstGeom prst="rect">
+            <a:avLst/>
+          </a:prstGeom>
+          <a:noFill/>
+          <a:ln/>
+        </p:spPr>
+        <p:txBody>
+          <a:bodyPr wrap="square" lIns="0" tIns="0" rIns="0" bIns="0" rtlCol="0" anchor="t"/>
+          <a:lstStyle/>
+          <a:p>
+            <a:pPr algn="ctr" indent="0" marL="0">
+              <a:buNone/>
+            </a:pPr>
+            <a:r>
+              <a:rPr lang="en-US" sz="1300" dirty="0">
+                <a:solidFill>
+                  <a:schemeClr val="tx2"/>
+                </a:solidFill>
+              </a:rPr>
+              <a:t>April review</a:t>
+            </a:r>
+            <a:endParaRPr lang="en-US" sz="1300" dirty="0"/>
+          </a:p>
+        </p:txBody>
+      </p:sp>
+      <p:sp>
+        <p:nvSpPr>
+          <p:cNvPr id="16" name="phase-b-2"/>
+          <p:cNvSpPr/>
+          <p:nvPr/>
+        </p:nvSpPr>
+        <p:spPr>
+          <a:xfrm>
+            <a:off x="6163056" y="2651760"/>
+            <a:ext cx="2606040" cy="2834640"/>
+          </a:xfrm>
+          <a:prstGeom prst="roundRect">
+            <a:avLst>
+              <a:gd name="adj" fmla="val 2807"/>
+            </a:avLst>
+          </a:prstGeom>
+          <a:solidFill>
+            <a:schemeClr val="bg2"/>
+          </a:solidFill>
+          <a:ln w="12700">
+            <a:solidFill>
+              <a:schemeClr val="bg2"/>
+            </a:solidFill>
+            <a:prstDash val="solid"/>
+          </a:ln>
+        </p:spPr>
+      </p:sp>
+      <p:sp>
+        <p:nvSpPr>
+          <p:cNvPr id="17" name="Text 15"/>
+          <p:cNvSpPr txBox="1"/>
+          <p:nvPr/>
+        </p:nvSpPr>
+        <p:spPr>
+          <a:xfrm>
+            <a:off x="6300216" y="2788920"/>
+            <a:ext cx="2377440" cy="2606040"/>
+          </a:xfrm>
+          <a:prstGeom prst="rect">
+            <a:avLst/>
+          </a:prstGeom>
+          <a:noFill/>
+          <a:ln/>
+        </p:spPr>
+        <p:txBody>
+          <a:bodyPr wrap="square" lIns="0" tIns="0" rIns="0" bIns="0" rtlCol="0" anchor="t"/>
+          <a:lstStyle/>
+          <a:p>
+            <a:pPr marL="342900" indent="-342900">
+              <a:spcAft>
+                <a:spcPts val="800"/>
+              </a:spcAft>
+              <a:buSzPct val="100000"/>
+              <a:buChar char="•"/>
+            </a:pPr>
+            <a:r>
+              <a:rPr lang="en-US" sz="1500" dirty="0">
+                <a:solidFill>
+                  <a:schemeClr val="tx1"/>
+                </a:solidFill>
+              </a:rPr>
+              <a:t>X3/X4 step 2</a:t>
+            </a:r>
+            <a:endParaRPr lang="en-US" sz="1500" dirty="0"/>
+          </a:p>
+          <a:p>
+            <a:pPr marL="342900" indent="-342900">
+              <a:spcAft>
+                <a:spcPts val="800"/>
+              </a:spcAft>
+              <a:buSzPct val="100000"/>
+              <a:buChar char="•"/>
+            </a:pPr>
+            <a:r>
+              <a:rPr lang="en-US" sz="1500" dirty="0">
+                <a:solidFill>
+                  <a:schemeClr val="tx1"/>
+                </a:solidFill>
+              </a:rPr>
+              <a:t>Results vs controls</a:t>
+            </a:r>
+            <a:endParaRPr lang="en-US" sz="1500" dirty="0"/>
+          </a:p>
+          <a:p>
+            <a:pPr marL="342900" indent="-342900">
+              <a:spcAft>
+                <a:spcPts val="800"/>
+              </a:spcAft>
+              <a:buSzPct val="100000"/>
+              <a:buChar char="•"/>
+            </a:pPr>
+            <a:r>
+              <a:rPr lang="en-US" sz="1500" dirty="0">
+                <a:solidFill>
+                  <a:schemeClr val="tx1"/>
+                </a:solidFill>
+              </a:rPr>
+              <a:t>Model v1 with justified targets</a:t>
+            </a:r>
+            <a:endParaRPr lang="en-US" sz="1500" dirty="0"/>
+          </a:p>
+          <a:p>
+            <a:pPr marL="342900" indent="-342900">
+              <a:spcAft>
+                <a:spcPts val="800"/>
+              </a:spcAft>
+              <a:buSzPct val="100000"/>
+              <a:buChar char="•"/>
+            </a:pPr>
+            <a:r>
+              <a:rPr lang="en-US" sz="1500" dirty="0">
+                <a:solidFill>
+                  <a:schemeClr val="tx1"/>
+                </a:solidFill>
+              </a:rPr>
+              <a:t>Decide which checks block</a:t>
+            </a:r>
+            <a:endParaRPr lang="en-US" sz="1500" dirty="0"/>
+          </a:p>
+        </p:txBody>
+      </p:sp>
+      <p:sp>
+        <p:nvSpPr>
+          <p:cNvPr id="18" name="phase-3"/>
+          <p:cNvSpPr/>
+          <p:nvPr/>
+        </p:nvSpPr>
+        <p:spPr>
+          <a:xfrm>
+            <a:off x="8970264" y="1371600"/>
+            <a:ext cx="2697480" cy="777240"/>
+          </a:xfrm>
+          <a:prstGeom prst="chevron">
+            <a:avLst/>
+          </a:prstGeom>
+          <a:solidFill>
+            <a:srgbClr val="1B2A41"/>
+          </a:solidFill>
+          <a:ln w="12700">
+            <a:solidFill>
+              <a:srgbClr val="1B2A41"/>
+            </a:solidFill>
+            <a:prstDash val="solid"/>
+          </a:ln>
+        </p:spPr>
+      </p:sp>
+      <p:sp>
+        <p:nvSpPr>
+          <p:cNvPr id="19" name="Text 17"/>
+          <p:cNvSpPr txBox="1"/>
+          <p:nvPr/>
+        </p:nvSpPr>
+        <p:spPr>
+          <a:xfrm>
+            <a:off x="9244584" y="1371600"/>
+            <a:ext cx="2148840" cy="777240"/>
+          </a:xfrm>
+          <a:prstGeom prst="rect">
+            <a:avLst/>
+          </a:prstGeom>
+          <a:noFill/>
+          <a:ln/>
+        </p:spPr>
+        <p:txBody>
+          <a:bodyPr wrap="square" lIns="0" tIns="0" rIns="0" bIns="0" rtlCol="0" anchor="ctr"/>
+          <a:lstStyle/>
+          <a:p>
+            <a:pPr algn="ctr" indent="0" marL="0">
+              <a:buNone/>
+            </a:pPr>
+            <a:r>
+              <a:rPr lang="en-US" sz="1800" b="1" dirty="0">
+                <a:solidFill>
+                  <a:schemeClr val="bg1"/>
+                </a:solidFill>
+              </a:rPr>
+              <a:t>H2 2027</a:t>
+            </a:r>
+            <a:endParaRPr lang="en-US" sz="1800" dirty="0"/>
+          </a:p>
+        </p:txBody>
+      </p:sp>
+      <p:sp>
+        <p:nvSpPr>
+          <p:cNvPr id="20" name="Text 18"/>
+          <p:cNvSpPr txBox="1"/>
+          <p:nvPr/>
+        </p:nvSpPr>
+        <p:spPr>
+          <a:xfrm>
+            <a:off x="8970264" y="2240280"/>
+            <a:ext cx="2606040" cy="320040"/>
+          </a:xfrm>
+          <a:prstGeom prst="rect">
+            <a:avLst/>
+          </a:prstGeom>
+          <a:noFill/>
+          <a:ln/>
+        </p:spPr>
+        <p:txBody>
+          <a:bodyPr wrap="square" lIns="0" tIns="0" rIns="0" bIns="0" rtlCol="0" anchor="t"/>
+          <a:lstStyle/>
+          <a:p>
+            <a:pPr algn="ctr" indent="0" marL="0">
+              <a:buNone/>
+            </a:pPr>
+            <a:r>
+              <a:rPr lang="en-US" sz="1300" dirty="0">
+                <a:solidFill>
+                  <a:schemeClr val="tx2"/>
+                </a:solidFill>
+              </a:rPr>
+              <a:t>Jul-Dec</a:t>
+            </a:r>
+            <a:endParaRPr lang="en-US" sz="1300" dirty="0"/>
+          </a:p>
+        </p:txBody>
+      </p:sp>
+      <p:sp>
+        <p:nvSpPr>
+          <p:cNvPr id="21" name="phase-b-3"/>
+          <p:cNvSpPr/>
+          <p:nvPr/>
+        </p:nvSpPr>
+        <p:spPr>
+          <a:xfrm>
+            <a:off x="8970264" y="2651760"/>
+            <a:ext cx="2606040" cy="2834640"/>
+          </a:xfrm>
+          <a:prstGeom prst="roundRect">
+            <a:avLst>
+              <a:gd name="adj" fmla="val 2807"/>
+            </a:avLst>
+          </a:prstGeom>
+          <a:solidFill>
+            <a:schemeClr val="bg2"/>
+          </a:solidFill>
+          <a:ln w="12700">
+            <a:solidFill>
+              <a:schemeClr val="bg2"/>
+            </a:solidFill>
+            <a:prstDash val="solid"/>
+          </a:ln>
+        </p:spPr>
+      </p:sp>
+      <p:sp>
+        <p:nvSpPr>
+          <p:cNvPr id="22" name="Text 20"/>
+          <p:cNvSpPr txBox="1"/>
+          <p:nvPr/>
+        </p:nvSpPr>
+        <p:spPr>
+          <a:xfrm>
+            <a:off x="9107424" y="2788920"/>
+            <a:ext cx="2377440" cy="2606040"/>
+          </a:xfrm>
+          <a:prstGeom prst="rect">
+            <a:avLst/>
+          </a:prstGeom>
+          <a:noFill/>
+          <a:ln/>
+        </p:spPr>
+        <p:txBody>
+          <a:bodyPr wrap="square" lIns="0" tIns="0" rIns="0" bIns="0" rtlCol="0" anchor="t"/>
+          <a:lstStyle/>
+          <a:p>
+            <a:pPr marL="342900" indent="-342900">
+              <a:spcAft>
+                <a:spcPts val="800"/>
+              </a:spcAft>
+              <a:buSzPct val="100000"/>
+              <a:buChar char="•"/>
+            </a:pPr>
+            <a:r>
+              <a:rPr lang="en-US" sz="1500" dirty="0">
+                <a:solidFill>
+                  <a:schemeClr val="tx1"/>
+                </a:solidFill>
+              </a:rPr>
+              <a:t>Spread proven practices to all domains</a:t>
+            </a:r>
+            <a:endParaRPr lang="en-US" sz="1500" dirty="0"/>
+          </a:p>
+          <a:p>
+            <a:pPr marL="342900" indent="-342900">
+              <a:spcAft>
+                <a:spcPts val="800"/>
+              </a:spcAft>
+              <a:buSzPct val="100000"/>
+              <a:buChar char="•"/>
+            </a:pPr>
+            <a:r>
+              <a:rPr lang="en-US" sz="1500" dirty="0">
+                <a:solidFill>
+                  <a:schemeClr val="tx1"/>
+                </a:solidFill>
+              </a:rPr>
+              <a:t>Decide RIA agents, mutation, harness from evidence</a:t>
+            </a:r>
+            <a:endParaRPr lang="en-US" sz="1500" dirty="0"/>
+          </a:p>
+        </p:txBody>
+      </p:sp>
+      <p:sp>
+        <p:nvSpPr>
+          <p:cNvPr id="25" name="Slide Number Placeholder 0"/>
+          <p:cNvSpPr>
+            <a:spLocks noGrp="1"/>
+          </p:cNvSpPr>
+          <p:nvPr>
+            <p:ph type="sldNum" sz="quarter" idx="4294967295"/>
+          </p:nvPr>
+        </p:nvSpPr>
+        <p:spPr>
+          <a:xfrm>
+            <a:off x="11247120" y="6400800"/>
+            <a:ext cx="457200" cy="274320"/>
+          </a:xfrm>
+          <a:prstGeom prst="rect">
+            <a:avLst/>
+          </a:prstGeom>
+          <a:extLst>
+            <a:ext uri="{C572A759-6A51-4108-AA02-DFA0A04FC94B}">
+              <ma14:wrappingTextBoxFlag xmlns:ma14="http://schemas.microsoft.com/office/mac/drawingml/2011/main" val="0"/>
+            </a:ext>
+          </a:extLst>
+        </p:spPr>
+        <p:txBody>
+          <a:bodyPr/>
+          <a:lstStyle>
+            <a:lvl1pPr>
+              <a:defRPr sz="1000">
+                <a:solidFill>
+                  <a:schemeClr val="tx2"/>
+                </a:solidFill>
+              </a:defRPr>
+            </a:lvl1pPr>
+          </a:lstStyle>
+          <a:p>
+            <a:pPr algn="r"/>
+            <a:fld id="{F7021451-1387-4CA6-816F-3879F97B5CBC}" type="slidenum">
+              <a:rPr b="0" lang="en-US"/>
+              <a:t>14</a:t>
+            </a:fld>
+            <a:endParaRPr lang="en-US"/>
+          </a:p>
+        </p:txBody>
+      </p:sp>
+    </p:spTree>
+  </p:cSld>
+  <p:clrMapOvr>
+    <a:masterClrMapping/>
+  </p:clrMapOvr>
+</p:sld>
+</file>
+
+<file path=ppt/slides/slide15.xml><?xml version="1.0" encoding="utf-8"?>
+<p:sld xmlns:a="http://schemas.openxmlformats.org/drawingml/2006/main" xmlns:r="http://schemas.openxmlformats.org/officeDocument/2006/relationships" xmlns:p="http://schemas.openxmlformats.org/presentationml/2006/main">
+  <p:cSld name="Slide 15">
+    <p:spTree>
+      <p:nvGrpSpPr>
+        <p:cNvPr id="1" name=""/>
+        <p:cNvGrpSpPr/>
+        <p:nvPr/>
+      </p:nvGrpSpPr>
+      <p:grpSpPr>
+        <a:xfrm>
+          <a:off x="0" y="0"/>
+          <a:ext cx="0" cy="0"/>
+          <a:chOff x="0" y="0"/>
+          <a:chExt cx="0" cy="0"/>
+        </a:xfrm>
+      </p:grpSpPr>
+      <p:sp>
+        <p:nvSpPr>
+          <p:cNvPr id="2" name="Text 0"/>
+          <p:cNvSpPr/>
+          <p:nvPr>
+            <p:ph idx="100" type="title" hasCustomPrompt="1"/>
+          </p:nvPr>
+        </p:nvSpPr>
+        <p:spPr>
+          <a:xfrm>
+            <a:off x="548640" y="320040"/>
+            <a:ext cx="11064240" cy="868680"/>
+          </a:xfrm>
+          <a:prstGeom prst="rect">
+            <a:avLst/>
+          </a:prstGeom>
+          <a:noFill/>
+          <a:ln/>
+        </p:spPr>
+        <p:txBody>
+          <a:bodyPr wrap="square" lIns="0" tIns="0" rIns="0" bIns="0" rtlCol="0" anchor="ctr"/>
+          <a:lstStyle/>
+          <a:p>
+            <a:pPr algn="l" indent="0" marL="0">
+              <a:buNone/>
+            </a:pPr>
+            <a:r>
+              <a:rPr lang="en-US" sz="3000" b="1" dirty="0">
+                <a:solidFill>
                   <a:schemeClr val="bg1"/>
                 </a:solidFill>
               </a:rPr>
@@ -10592,7 +12450,7 @@
             <a:pPr algn="r"/>
             <a:fld id="{F7021451-1387-4CA6-816F-3879F97B5CBC}" type="slidenum">
               <a:rPr b="0" lang="en-US"/>
-              <a:t>14</a:t>
+              <a:t>15</a:t>
             </a:fld>
             <a:endParaRPr lang="en-US"/>
           </a:p>

</xml_diff>